<commit_message>
Wizard user guide deck: use real CSHSE logo from client/public/cshse-logo.svg
Coordinator feedback: the deck wasn't using the actual CSHSE logo from
the application's top-left brand chip. Pulled the SVG from
client/public/cshse-logo.svg (the same asset the LoginPage and Layout
component use), rasterized to a 1024px PNG via sharp, and embedded it:

  - Top brand bar on every content slide: 0.32-inch logo at the left
    instead of the redundant 'CSHSE ·' text prefix.
  - Title slide: 1.5-inch logo replaces the FaRocket placeholder.
  - Closing slide: 1.3-inch logo replaces the FaCheckCircle placeholder.

Now committed alongside the deck:
  - cshse-logo.png — the rasterized 1024x1024 asset (49 KB).
  - wizard-user-guide-2026-05-20.deck.js — the pptxgenjs build script
    so the deck can be regenerated reproducibly (e.g. after a wizard
    UX change).

Co-Authored-By: Claude Opus 4.7 (1M context) <noreply@anthropic.com>
</commit_message>
<xml_diff>
--- a/CSHSE/CSHSE/Engineering/wizard-user-guide-2026-05-20.pptx
+++ b/CSHSE/CSHSE/Engineering/wizard-user-guide-2026-05-20.pptx
@@ -2369,8 +2369,8 @@
         </p:blipFill>
         <p:spPr>
           <a:xfrm>
-            <a:off x="731520" y="914400"/>
-            <a:ext cx="822960" cy="822960"/>
+            <a:off x="731520" y="502920"/>
+            <a:ext cx="1371600" cy="1371600"/>
           </a:xfrm>
           <a:prstGeom prst="rect">
             <a:avLst/>
@@ -2385,8 +2385,8 @@
         </p:nvSpPr>
         <p:spPr>
           <a:xfrm>
-            <a:off x="731520" y="1828800"/>
-            <a:ext cx="3657600" cy="365760"/>
+            <a:off x="457200" y="1965960"/>
+            <a:ext cx="3657600" cy="274320"/>
           </a:xfrm>
           <a:prstGeom prst="rect">
             <a:avLst/>
@@ -2398,11 +2398,11 @@
           <a:bodyPr wrap="square" lIns="0" tIns="0" rIns="0" bIns="0" rtlCol="0" anchor="ctr"/>
           <a:lstStyle/>
           <a:p>
-            <a:pPr indent="0" marL="0">
-              <a:buNone/>
-            </a:pPr>
-            <a:r>
-              <a:rPr lang="en-US" sz="1400" b="1" spc="800" kern="0" dirty="0">
+            <a:pPr algn="l" indent="0" marL="0">
+              <a:buNone/>
+            </a:pPr>
+            <a:r>
+              <a:rPr lang="en-US" sz="1100" b="1" dirty="0">
                 <a:solidFill>
                   <a:srgbClr val="81C784"/>
                 </a:solidFill>
@@ -2410,9 +2410,9 @@
                 <a:ea typeface="Calibri" pitchFamily="34" charset="-122"/>
                 <a:cs typeface="Calibri" pitchFamily="34" charset="-120"/>
               </a:rPr>
-              <a:t>CSHSE</a:t>
-            </a:r>
-            <a:endParaRPr lang="en-US" sz="1400" dirty="0"/>
+              <a:t>Council for Standards in Human Service Education</a:t>
+            </a:r>
+            <a:endParaRPr lang="en-US" sz="1100" dirty="0"/>
           </a:p>
         </p:txBody>
       </p:sp>
@@ -2424,8 +2424,8 @@
         </p:nvSpPr>
         <p:spPr>
           <a:xfrm>
-            <a:off x="731520" y="2194560"/>
-            <a:ext cx="3657600" cy="822960"/>
+            <a:off x="457200" y="2331720"/>
+            <a:ext cx="3657600" cy="731520"/>
           </a:xfrm>
           <a:prstGeom prst="rect">
             <a:avLst/>
@@ -2441,7 +2441,7 @@
               <a:buNone/>
             </a:pPr>
             <a:r>
-              <a:rPr lang="en-US" sz="3600" b="1" dirty="0">
+              <a:rPr lang="en-US" sz="3400" b="1" dirty="0">
                 <a:solidFill>
                   <a:srgbClr val="FFFFFF"/>
                 </a:solidFill>
@@ -2451,7 +2451,7 @@
               </a:rPr>
               <a:t>AI Import Wizard</a:t>
             </a:r>
-            <a:endParaRPr lang="en-US" sz="3600" dirty="0"/>
+            <a:endParaRPr lang="en-US" sz="3400" dirty="0"/>
           </a:p>
         </p:txBody>
       </p:sp>
@@ -2463,7 +2463,7 @@
         </p:nvSpPr>
         <p:spPr>
           <a:xfrm>
-            <a:off x="731520" y="3017520"/>
+            <a:off x="457200" y="3063240"/>
             <a:ext cx="3657600" cy="365760"/>
           </a:xfrm>
           <a:prstGeom prst="rect">
@@ -2643,16 +2643,40 @@
           </a:ln>
         </p:spPr>
       </p:sp>
-      <p:sp>
-        <p:nvSpPr>
-          <p:cNvPr id="3" name="Text 1"/>
-          <p:cNvSpPr/>
-          <p:nvPr/>
-        </p:nvSpPr>
-        <p:spPr>
-          <a:xfrm>
-            <a:off x="365760" y="0"/>
-            <a:ext cx="8412480" cy="365760"/>
+      <p:pic>
+        <p:nvPicPr>
+          <p:cNvPr id="3" name="Image 0" descr="preencoded.png">    </p:cNvPr>
+          <p:cNvPicPr>
+            <a:picLocks noChangeAspect="1"/>
+          </p:cNvPicPr>
+          <p:nvPr/>
+        </p:nvPicPr>
+        <p:blipFill>
+          <a:blip r:embed="rId1"/>
+          <a:stretch>
+            <a:fillRect/>
+          </a:stretch>
+        </p:blipFill>
+        <p:spPr>
+          <a:xfrm>
+            <a:off x="91440" y="36576"/>
+            <a:ext cx="292608" cy="292608"/>
+          </a:xfrm>
+          <a:prstGeom prst="rect">
+            <a:avLst/>
+          </a:prstGeom>
+        </p:spPr>
+      </p:pic>
+      <p:sp>
+        <p:nvSpPr>
+          <p:cNvPr id="4" name="Text 1"/>
+          <p:cNvSpPr/>
+          <p:nvPr/>
+        </p:nvSpPr>
+        <p:spPr>
+          <a:xfrm>
+            <a:off x="457200" y="0"/>
+            <a:ext cx="8229600" cy="365760"/>
           </a:xfrm>
           <a:prstGeom prst="rect">
             <a:avLst/>
@@ -2676,7 +2700,7 @@
                 <a:ea typeface="Calibri" pitchFamily="34" charset="-122"/>
                 <a:cs typeface="Calibri" pitchFamily="34" charset="-120"/>
               </a:rPr>
-              <a:t>CSHSE · AI Import Wizard · User Guide</a:t>
+              <a:t>AI Import Wizard · User Guide</a:t>
             </a:r>
             <a:endParaRPr lang="en-US" sz="1000" dirty="0"/>
           </a:p>
@@ -2684,7 +2708,7 @@
       </p:sp>
       <p:sp>
         <p:nvSpPr>
-          <p:cNvPr id="4" name="Text 2"/>
+          <p:cNvPr id="5" name="Text 2"/>
           <p:cNvSpPr/>
           <p:nvPr/>
         </p:nvSpPr>
@@ -2723,7 +2747,7 @@
       </p:sp>
       <p:sp>
         <p:nvSpPr>
-          <p:cNvPr id="5" name="Text 3"/>
+          <p:cNvPr id="6" name="Text 3"/>
           <p:cNvSpPr/>
           <p:nvPr/>
         </p:nvSpPr>
@@ -2762,7 +2786,7 @@
       </p:sp>
       <p:sp>
         <p:nvSpPr>
-          <p:cNvPr id="6" name="Shape 4"/>
+          <p:cNvPr id="7" name="Shape 4"/>
           <p:cNvSpPr/>
           <p:nvPr/>
         </p:nvSpPr>
@@ -2794,7 +2818,7 @@
       </p:sp>
       <p:sp>
         <p:nvSpPr>
-          <p:cNvPr id="7" name="Shape 5"/>
+          <p:cNvPr id="8" name="Shape 5"/>
           <p:cNvSpPr/>
           <p:nvPr/>
         </p:nvSpPr>
@@ -2819,14 +2843,14 @@
       </p:sp>
       <p:pic>
         <p:nvPicPr>
-          <p:cNvPr id="8" name="Image 0" descr="preencoded.png">    </p:cNvPr>
+          <p:cNvPr id="9" name="Image 1" descr="preencoded.png">    </p:cNvPr>
           <p:cNvPicPr>
             <a:picLocks noChangeAspect="1"/>
           </p:cNvPicPr>
           <p:nvPr/>
         </p:nvPicPr>
         <p:blipFill>
-          <a:blip r:embed="rId1"/>
+          <a:blip r:embed="rId2"/>
           <a:stretch>
             <a:fillRect/>
           </a:stretch>
@@ -2843,7 +2867,7 @@
       </p:pic>
       <p:sp>
         <p:nvSpPr>
-          <p:cNvPr id="9" name="Text 6"/>
+          <p:cNvPr id="10" name="Text 6"/>
           <p:cNvSpPr/>
           <p:nvPr/>
         </p:nvSpPr>
@@ -2882,7 +2906,7 @@
       </p:sp>
       <p:sp>
         <p:nvSpPr>
-          <p:cNvPr id="10" name="Text 7"/>
+          <p:cNvPr id="11" name="Text 7"/>
           <p:cNvSpPr/>
           <p:nvPr/>
         </p:nvSpPr>
@@ -2921,7 +2945,7 @@
       </p:sp>
       <p:sp>
         <p:nvSpPr>
-          <p:cNvPr id="11" name="Shape 8"/>
+          <p:cNvPr id="12" name="Shape 8"/>
           <p:cNvSpPr/>
           <p:nvPr/>
         </p:nvSpPr>
@@ -2953,7 +2977,7 @@
       </p:sp>
       <p:sp>
         <p:nvSpPr>
-          <p:cNvPr id="12" name="Shape 9"/>
+          <p:cNvPr id="13" name="Shape 9"/>
           <p:cNvSpPr/>
           <p:nvPr/>
         </p:nvSpPr>
@@ -2978,14 +3002,14 @@
       </p:sp>
       <p:pic>
         <p:nvPicPr>
-          <p:cNvPr id="13" name="Image 1" descr="preencoded.png">    </p:cNvPr>
+          <p:cNvPr id="14" name="Image 2" descr="preencoded.png">    </p:cNvPr>
           <p:cNvPicPr>
             <a:picLocks noChangeAspect="1"/>
           </p:cNvPicPr>
           <p:nvPr/>
         </p:nvPicPr>
         <p:blipFill>
-          <a:blip r:embed="rId2"/>
+          <a:blip r:embed="rId3"/>
           <a:stretch>
             <a:fillRect/>
           </a:stretch>
@@ -3002,7 +3026,7 @@
       </p:pic>
       <p:sp>
         <p:nvSpPr>
-          <p:cNvPr id="14" name="Text 10"/>
+          <p:cNvPr id="15" name="Text 10"/>
           <p:cNvSpPr/>
           <p:nvPr/>
         </p:nvSpPr>
@@ -3041,7 +3065,7 @@
       </p:sp>
       <p:sp>
         <p:nvSpPr>
-          <p:cNvPr id="15" name="Text 11"/>
+          <p:cNvPr id="16" name="Text 11"/>
           <p:cNvSpPr/>
           <p:nvPr/>
         </p:nvSpPr>
@@ -3080,7 +3104,7 @@
       </p:sp>
       <p:sp>
         <p:nvSpPr>
-          <p:cNvPr id="16" name="Shape 12"/>
+          <p:cNvPr id="17" name="Shape 12"/>
           <p:cNvSpPr/>
           <p:nvPr/>
         </p:nvSpPr>
@@ -3112,7 +3136,7 @@
       </p:sp>
       <p:sp>
         <p:nvSpPr>
-          <p:cNvPr id="17" name="Shape 13"/>
+          <p:cNvPr id="18" name="Shape 13"/>
           <p:cNvSpPr/>
           <p:nvPr/>
         </p:nvSpPr>
@@ -3137,14 +3161,14 @@
       </p:sp>
       <p:pic>
         <p:nvPicPr>
-          <p:cNvPr id="18" name="Image 2" descr="preencoded.png">    </p:cNvPr>
+          <p:cNvPr id="19" name="Image 3" descr="preencoded.png">    </p:cNvPr>
           <p:cNvPicPr>
             <a:picLocks noChangeAspect="1"/>
           </p:cNvPicPr>
           <p:nvPr/>
         </p:nvPicPr>
         <p:blipFill>
-          <a:blip r:embed="rId3"/>
+          <a:blip r:embed="rId4"/>
           <a:stretch>
             <a:fillRect/>
           </a:stretch>
@@ -3161,7 +3185,7 @@
       </p:pic>
       <p:sp>
         <p:nvSpPr>
-          <p:cNvPr id="19" name="Text 14"/>
+          <p:cNvPr id="20" name="Text 14"/>
           <p:cNvSpPr/>
           <p:nvPr/>
         </p:nvSpPr>
@@ -3200,7 +3224,7 @@
       </p:sp>
       <p:sp>
         <p:nvSpPr>
-          <p:cNvPr id="20" name="Text 15"/>
+          <p:cNvPr id="21" name="Text 15"/>
           <p:cNvSpPr/>
           <p:nvPr/>
         </p:nvSpPr>
@@ -3239,7 +3263,7 @@
       </p:sp>
       <p:sp>
         <p:nvSpPr>
-          <p:cNvPr id="21" name="Shape 16"/>
+          <p:cNvPr id="22" name="Shape 16"/>
           <p:cNvSpPr/>
           <p:nvPr/>
         </p:nvSpPr>
@@ -3264,14 +3288,14 @@
       </p:sp>
       <p:pic>
         <p:nvPicPr>
-          <p:cNvPr id="22" name="Image 3" descr="preencoded.png">    </p:cNvPr>
+          <p:cNvPr id="23" name="Image 4" descr="preencoded.png">    </p:cNvPr>
           <p:cNvPicPr>
             <a:picLocks noChangeAspect="1"/>
           </p:cNvPicPr>
           <p:nvPr/>
         </p:nvPicPr>
         <p:blipFill>
-          <a:blip r:embed="rId4"/>
+          <a:blip r:embed="rId5"/>
           <a:stretch>
             <a:fillRect/>
           </a:stretch>
@@ -3288,7 +3312,7 @@
       </p:pic>
       <p:sp>
         <p:nvSpPr>
-          <p:cNvPr id="23" name="Text 17"/>
+          <p:cNvPr id="24" name="Text 17"/>
           <p:cNvSpPr/>
           <p:nvPr/>
         </p:nvSpPr>
@@ -3327,7 +3351,7 @@
       </p:sp>
       <p:sp>
         <p:nvSpPr>
-          <p:cNvPr id="24" name="Shape 18"/>
+          <p:cNvPr id="25" name="Shape 18"/>
           <p:cNvSpPr/>
           <p:nvPr/>
         </p:nvSpPr>
@@ -3352,7 +3376,7 @@
       </p:sp>
       <p:sp>
         <p:nvSpPr>
-          <p:cNvPr id="25" name="Text 19"/>
+          <p:cNvPr id="26" name="Text 19"/>
           <p:cNvSpPr/>
           <p:nvPr/>
         </p:nvSpPr>
@@ -3446,16 +3470,40 @@
           </a:ln>
         </p:spPr>
       </p:sp>
-      <p:sp>
-        <p:nvSpPr>
-          <p:cNvPr id="3" name="Text 1"/>
-          <p:cNvSpPr/>
-          <p:nvPr/>
-        </p:nvSpPr>
-        <p:spPr>
-          <a:xfrm>
-            <a:off x="365760" y="0"/>
-            <a:ext cx="8412480" cy="365760"/>
+      <p:pic>
+        <p:nvPicPr>
+          <p:cNvPr id="3" name="Image 0" descr="preencoded.png">    </p:cNvPr>
+          <p:cNvPicPr>
+            <a:picLocks noChangeAspect="1"/>
+          </p:cNvPicPr>
+          <p:nvPr/>
+        </p:nvPicPr>
+        <p:blipFill>
+          <a:blip r:embed="rId1"/>
+          <a:stretch>
+            <a:fillRect/>
+          </a:stretch>
+        </p:blipFill>
+        <p:spPr>
+          <a:xfrm>
+            <a:off x="91440" y="36576"/>
+            <a:ext cx="292608" cy="292608"/>
+          </a:xfrm>
+          <a:prstGeom prst="rect">
+            <a:avLst/>
+          </a:prstGeom>
+        </p:spPr>
+      </p:pic>
+      <p:sp>
+        <p:nvSpPr>
+          <p:cNvPr id="4" name="Text 1"/>
+          <p:cNvSpPr/>
+          <p:nvPr/>
+        </p:nvSpPr>
+        <p:spPr>
+          <a:xfrm>
+            <a:off x="457200" y="0"/>
+            <a:ext cx="8229600" cy="365760"/>
           </a:xfrm>
           <a:prstGeom prst="rect">
             <a:avLst/>
@@ -3479,7 +3527,7 @@
                 <a:ea typeface="Calibri" pitchFamily="34" charset="-122"/>
                 <a:cs typeface="Calibri" pitchFamily="34" charset="-120"/>
               </a:rPr>
-              <a:t>CSHSE · AI Import Wizard · User Guide</a:t>
+              <a:t>AI Import Wizard · User Guide</a:t>
             </a:r>
             <a:endParaRPr lang="en-US" sz="1000" dirty="0"/>
           </a:p>
@@ -3487,7 +3535,7 @@
       </p:sp>
       <p:sp>
         <p:nvSpPr>
-          <p:cNvPr id="4" name="Text 2"/>
+          <p:cNvPr id="5" name="Text 2"/>
           <p:cNvSpPr/>
           <p:nvPr/>
         </p:nvSpPr>
@@ -3526,7 +3574,7 @@
       </p:sp>
       <p:sp>
         <p:nvSpPr>
-          <p:cNvPr id="5" name="Text 3"/>
+          <p:cNvPr id="6" name="Text 3"/>
           <p:cNvSpPr/>
           <p:nvPr/>
         </p:nvSpPr>
@@ -3565,7 +3613,7 @@
       </p:sp>
       <p:sp>
         <p:nvSpPr>
-          <p:cNvPr id="6" name="Shape 4"/>
+          <p:cNvPr id="7" name="Shape 4"/>
           <p:cNvSpPr/>
           <p:nvPr/>
         </p:nvSpPr>
@@ -3597,7 +3645,7 @@
       </p:sp>
       <p:sp>
         <p:nvSpPr>
-          <p:cNvPr id="7" name="Shape 5"/>
+          <p:cNvPr id="8" name="Shape 5"/>
           <p:cNvSpPr/>
           <p:nvPr/>
         </p:nvSpPr>
@@ -3622,7 +3670,7 @@
       </p:sp>
       <p:sp>
         <p:nvSpPr>
-          <p:cNvPr id="8" name="Text 6"/>
+          <p:cNvPr id="9" name="Text 6"/>
           <p:cNvSpPr/>
           <p:nvPr/>
         </p:nvSpPr>
@@ -3661,7 +3709,7 @@
       </p:sp>
       <p:sp>
         <p:nvSpPr>
-          <p:cNvPr id="9" name="Text 7"/>
+          <p:cNvPr id="10" name="Text 7"/>
           <p:cNvSpPr/>
           <p:nvPr/>
         </p:nvSpPr>
@@ -3769,7 +3817,7 @@
       </p:sp>
       <p:sp>
         <p:nvSpPr>
-          <p:cNvPr id="10" name="Shape 8"/>
+          <p:cNvPr id="11" name="Shape 8"/>
           <p:cNvSpPr/>
           <p:nvPr/>
         </p:nvSpPr>
@@ -3801,7 +3849,7 @@
       </p:sp>
       <p:sp>
         <p:nvSpPr>
-          <p:cNvPr id="11" name="Shape 9"/>
+          <p:cNvPr id="12" name="Shape 9"/>
           <p:cNvSpPr/>
           <p:nvPr/>
         </p:nvSpPr>
@@ -3826,7 +3874,7 @@
       </p:sp>
       <p:sp>
         <p:nvSpPr>
-          <p:cNvPr id="12" name="Text 10"/>
+          <p:cNvPr id="13" name="Text 10"/>
           <p:cNvSpPr/>
           <p:nvPr/>
         </p:nvSpPr>
@@ -3865,7 +3913,7 @@
       </p:sp>
       <p:sp>
         <p:nvSpPr>
-          <p:cNvPr id="13" name="Text 11"/>
+          <p:cNvPr id="14" name="Text 11"/>
           <p:cNvSpPr/>
           <p:nvPr/>
         </p:nvSpPr>
@@ -4025,7 +4073,7 @@
       </p:sp>
       <p:sp>
         <p:nvSpPr>
-          <p:cNvPr id="14" name="Shape 12"/>
+          <p:cNvPr id="15" name="Shape 12"/>
           <p:cNvSpPr/>
           <p:nvPr/>
         </p:nvSpPr>
@@ -4050,7 +4098,7 @@
       </p:sp>
       <p:sp>
         <p:nvSpPr>
-          <p:cNvPr id="15" name="Text 13"/>
+          <p:cNvPr id="16" name="Text 13"/>
           <p:cNvSpPr/>
           <p:nvPr/>
         </p:nvSpPr>
@@ -4144,16 +4192,40 @@
           </a:ln>
         </p:spPr>
       </p:sp>
-      <p:sp>
-        <p:nvSpPr>
-          <p:cNvPr id="3" name="Text 1"/>
-          <p:cNvSpPr/>
-          <p:nvPr/>
-        </p:nvSpPr>
-        <p:spPr>
-          <a:xfrm>
-            <a:off x="365760" y="0"/>
-            <a:ext cx="8412480" cy="365760"/>
+      <p:pic>
+        <p:nvPicPr>
+          <p:cNvPr id="3" name="Image 0" descr="preencoded.png">    </p:cNvPr>
+          <p:cNvPicPr>
+            <a:picLocks noChangeAspect="1"/>
+          </p:cNvPicPr>
+          <p:nvPr/>
+        </p:nvPicPr>
+        <p:blipFill>
+          <a:blip r:embed="rId1"/>
+          <a:stretch>
+            <a:fillRect/>
+          </a:stretch>
+        </p:blipFill>
+        <p:spPr>
+          <a:xfrm>
+            <a:off x="91440" y="36576"/>
+            <a:ext cx="292608" cy="292608"/>
+          </a:xfrm>
+          <a:prstGeom prst="rect">
+            <a:avLst/>
+          </a:prstGeom>
+        </p:spPr>
+      </p:pic>
+      <p:sp>
+        <p:nvSpPr>
+          <p:cNvPr id="4" name="Text 1"/>
+          <p:cNvSpPr/>
+          <p:nvPr/>
+        </p:nvSpPr>
+        <p:spPr>
+          <a:xfrm>
+            <a:off x="457200" y="0"/>
+            <a:ext cx="8229600" cy="365760"/>
           </a:xfrm>
           <a:prstGeom prst="rect">
             <a:avLst/>
@@ -4177,7 +4249,7 @@
                 <a:ea typeface="Calibri" pitchFamily="34" charset="-122"/>
                 <a:cs typeface="Calibri" pitchFamily="34" charset="-120"/>
               </a:rPr>
-              <a:t>CSHSE · AI Import Wizard · User Guide</a:t>
+              <a:t>AI Import Wizard · User Guide</a:t>
             </a:r>
             <a:endParaRPr lang="en-US" sz="1000" dirty="0"/>
           </a:p>
@@ -4185,7 +4257,7 @@
       </p:sp>
       <p:sp>
         <p:nvSpPr>
-          <p:cNvPr id="4" name="Text 2"/>
+          <p:cNvPr id="5" name="Text 2"/>
           <p:cNvSpPr/>
           <p:nvPr/>
         </p:nvSpPr>
@@ -4224,7 +4296,7 @@
       </p:sp>
       <p:sp>
         <p:nvSpPr>
-          <p:cNvPr id="5" name="Text 3"/>
+          <p:cNvPr id="6" name="Text 3"/>
           <p:cNvSpPr/>
           <p:nvPr/>
         </p:nvSpPr>
@@ -4263,7 +4335,7 @@
       </p:sp>
       <p:sp>
         <p:nvSpPr>
-          <p:cNvPr id="6" name="Shape 4"/>
+          <p:cNvPr id="7" name="Shape 4"/>
           <p:cNvSpPr/>
           <p:nvPr/>
         </p:nvSpPr>
@@ -4295,7 +4367,7 @@
       </p:sp>
       <p:sp>
         <p:nvSpPr>
-          <p:cNvPr id="7" name="Text 5"/>
+          <p:cNvPr id="8" name="Text 5"/>
           <p:cNvSpPr/>
           <p:nvPr/>
         </p:nvSpPr>
@@ -5030,7 +5102,7 @@
       </p:graphicFrame>
       <p:sp>
         <p:nvSpPr>
-          <p:cNvPr id="9" name="Shape 6"/>
+          <p:cNvPr id="10" name="Shape 6"/>
           <p:cNvSpPr/>
           <p:nvPr/>
         </p:nvSpPr>
@@ -5062,7 +5134,7 @@
       </p:sp>
       <p:sp>
         <p:nvSpPr>
-          <p:cNvPr id="10" name="Text 7"/>
+          <p:cNvPr id="11" name="Text 7"/>
           <p:cNvSpPr/>
           <p:nvPr/>
         </p:nvSpPr>
@@ -5665,7 +5737,7 @@
       </p:graphicFrame>
       <p:sp>
         <p:nvSpPr>
-          <p:cNvPr id="12" name="Shape 8"/>
+          <p:cNvPr id="13" name="Shape 8"/>
           <p:cNvSpPr/>
           <p:nvPr/>
         </p:nvSpPr>
@@ -5690,7 +5762,7 @@
       </p:sp>
       <p:sp>
         <p:nvSpPr>
-          <p:cNvPr id="13" name="Text 9"/>
+          <p:cNvPr id="14" name="Text 9"/>
           <p:cNvSpPr/>
           <p:nvPr/>
         </p:nvSpPr>
@@ -5743,7 +5815,7 @@
       </p:sp>
       <p:sp>
         <p:nvSpPr>
-          <p:cNvPr id="14" name="Shape 10"/>
+          <p:cNvPr id="15" name="Shape 10"/>
           <p:cNvSpPr/>
           <p:nvPr/>
         </p:nvSpPr>
@@ -5768,7 +5840,7 @@
       </p:sp>
       <p:sp>
         <p:nvSpPr>
-          <p:cNvPr id="15" name="Text 11"/>
+          <p:cNvPr id="16" name="Text 11"/>
           <p:cNvSpPr/>
           <p:nvPr/>
         </p:nvSpPr>
@@ -5862,16 +5934,40 @@
           </a:ln>
         </p:spPr>
       </p:sp>
-      <p:sp>
-        <p:nvSpPr>
-          <p:cNvPr id="3" name="Text 1"/>
-          <p:cNvSpPr/>
-          <p:nvPr/>
-        </p:nvSpPr>
-        <p:spPr>
-          <a:xfrm>
-            <a:off x="365760" y="0"/>
-            <a:ext cx="8412480" cy="365760"/>
+      <p:pic>
+        <p:nvPicPr>
+          <p:cNvPr id="3" name="Image 0" descr="preencoded.png">    </p:cNvPr>
+          <p:cNvPicPr>
+            <a:picLocks noChangeAspect="1"/>
+          </p:cNvPicPr>
+          <p:nvPr/>
+        </p:nvPicPr>
+        <p:blipFill>
+          <a:blip r:embed="rId1"/>
+          <a:stretch>
+            <a:fillRect/>
+          </a:stretch>
+        </p:blipFill>
+        <p:spPr>
+          <a:xfrm>
+            <a:off x="91440" y="36576"/>
+            <a:ext cx="292608" cy="292608"/>
+          </a:xfrm>
+          <a:prstGeom prst="rect">
+            <a:avLst/>
+          </a:prstGeom>
+        </p:spPr>
+      </p:pic>
+      <p:sp>
+        <p:nvSpPr>
+          <p:cNvPr id="4" name="Text 1"/>
+          <p:cNvSpPr/>
+          <p:nvPr/>
+        </p:nvSpPr>
+        <p:spPr>
+          <a:xfrm>
+            <a:off x="457200" y="0"/>
+            <a:ext cx="8229600" cy="365760"/>
           </a:xfrm>
           <a:prstGeom prst="rect">
             <a:avLst/>
@@ -5895,7 +5991,7 @@
                 <a:ea typeface="Calibri" pitchFamily="34" charset="-122"/>
                 <a:cs typeface="Calibri" pitchFamily="34" charset="-120"/>
               </a:rPr>
-              <a:t>CSHSE · AI Import Wizard · User Guide</a:t>
+              <a:t>AI Import Wizard · User Guide</a:t>
             </a:r>
             <a:endParaRPr lang="en-US" sz="1000" dirty="0"/>
           </a:p>
@@ -5903,7 +5999,7 @@
       </p:sp>
       <p:sp>
         <p:nvSpPr>
-          <p:cNvPr id="4" name="Text 2"/>
+          <p:cNvPr id="5" name="Text 2"/>
           <p:cNvSpPr/>
           <p:nvPr/>
         </p:nvSpPr>
@@ -5942,7 +6038,7 @@
       </p:sp>
       <p:sp>
         <p:nvSpPr>
-          <p:cNvPr id="5" name="Text 3"/>
+          <p:cNvPr id="6" name="Text 3"/>
           <p:cNvSpPr/>
           <p:nvPr/>
         </p:nvSpPr>
@@ -5981,7 +6077,7 @@
       </p:sp>
       <p:sp>
         <p:nvSpPr>
-          <p:cNvPr id="6" name="Shape 4"/>
+          <p:cNvPr id="7" name="Shape 4"/>
           <p:cNvSpPr/>
           <p:nvPr/>
         </p:nvSpPr>
@@ -6013,7 +6109,7 @@
       </p:sp>
       <p:sp>
         <p:nvSpPr>
-          <p:cNvPr id="7" name="Text 5"/>
+          <p:cNvPr id="8" name="Text 5"/>
           <p:cNvSpPr/>
           <p:nvPr/>
         </p:nvSpPr>
@@ -6052,7 +6148,7 @@
       </p:sp>
       <p:sp>
         <p:nvSpPr>
-          <p:cNvPr id="8" name="Text 6"/>
+          <p:cNvPr id="9" name="Text 6"/>
           <p:cNvSpPr/>
           <p:nvPr/>
         </p:nvSpPr>
@@ -6091,7 +6187,7 @@
       </p:sp>
       <p:sp>
         <p:nvSpPr>
-          <p:cNvPr id="9" name="Shape 7"/>
+          <p:cNvPr id="10" name="Shape 7"/>
           <p:cNvSpPr/>
           <p:nvPr/>
         </p:nvSpPr>
@@ -6116,14 +6212,14 @@
       </p:sp>
       <p:pic>
         <p:nvPicPr>
-          <p:cNvPr id="10" name="Image 0" descr="preencoded.png">    </p:cNvPr>
+          <p:cNvPr id="11" name="Image 1" descr="preencoded.png">    </p:cNvPr>
           <p:cNvPicPr>
             <a:picLocks noChangeAspect="1"/>
           </p:cNvPicPr>
           <p:nvPr/>
         </p:nvPicPr>
         <p:blipFill>
-          <a:blip r:embed="rId1"/>
+          <a:blip r:embed="rId2"/>
           <a:stretch>
             <a:fillRect/>
           </a:stretch>
@@ -6140,7 +6236,7 @@
       </p:pic>
       <p:sp>
         <p:nvSpPr>
-          <p:cNvPr id="11" name="Text 8"/>
+          <p:cNvPr id="12" name="Text 8"/>
           <p:cNvSpPr/>
           <p:nvPr/>
         </p:nvSpPr>
@@ -6179,7 +6275,7 @@
       </p:sp>
       <p:sp>
         <p:nvSpPr>
-          <p:cNvPr id="12" name="Text 9"/>
+          <p:cNvPr id="13" name="Text 9"/>
           <p:cNvSpPr/>
           <p:nvPr/>
         </p:nvSpPr>
@@ -6218,7 +6314,7 @@
       </p:sp>
       <p:sp>
         <p:nvSpPr>
-          <p:cNvPr id="13" name="Text 10"/>
+          <p:cNvPr id="14" name="Text 10"/>
           <p:cNvSpPr/>
           <p:nvPr/>
         </p:nvSpPr>
@@ -6257,7 +6353,7 @@
       </p:sp>
       <p:sp>
         <p:nvSpPr>
-          <p:cNvPr id="14" name="Text 11"/>
+          <p:cNvPr id="15" name="Text 11"/>
           <p:cNvSpPr/>
           <p:nvPr/>
         </p:nvSpPr>
@@ -6296,7 +6392,7 @@
       </p:sp>
       <p:sp>
         <p:nvSpPr>
-          <p:cNvPr id="15" name="Shape 12"/>
+          <p:cNvPr id="16" name="Shape 12"/>
           <p:cNvSpPr/>
           <p:nvPr/>
         </p:nvSpPr>
@@ -6328,7 +6424,7 @@
       </p:sp>
       <p:sp>
         <p:nvSpPr>
-          <p:cNvPr id="16" name="Text 13"/>
+          <p:cNvPr id="17" name="Text 13"/>
           <p:cNvSpPr/>
           <p:nvPr/>
         </p:nvSpPr>
@@ -6367,7 +6463,7 @@
       </p:sp>
       <p:sp>
         <p:nvSpPr>
-          <p:cNvPr id="17" name="Text 14"/>
+          <p:cNvPr id="18" name="Text 14"/>
           <p:cNvSpPr/>
           <p:nvPr/>
         </p:nvSpPr>
@@ -6406,7 +6502,7 @@
       </p:sp>
       <p:sp>
         <p:nvSpPr>
-          <p:cNvPr id="18" name="Shape 15"/>
+          <p:cNvPr id="19" name="Shape 15"/>
           <p:cNvSpPr/>
           <p:nvPr/>
         </p:nvSpPr>
@@ -6431,7 +6527,7 @@
       </p:sp>
       <p:sp>
         <p:nvSpPr>
-          <p:cNvPr id="19" name="Text 16"/>
+          <p:cNvPr id="20" name="Text 16"/>
           <p:cNvSpPr/>
           <p:nvPr/>
         </p:nvSpPr>
@@ -6538,7 +6634,7 @@
       </p:sp>
       <p:sp>
         <p:nvSpPr>
-          <p:cNvPr id="20" name="Shape 17"/>
+          <p:cNvPr id="21" name="Shape 17"/>
           <p:cNvSpPr/>
           <p:nvPr/>
         </p:nvSpPr>
@@ -6563,7 +6659,7 @@
       </p:sp>
       <p:sp>
         <p:nvSpPr>
-          <p:cNvPr id="21" name="Text 18"/>
+          <p:cNvPr id="22" name="Text 18"/>
           <p:cNvSpPr/>
           <p:nvPr/>
         </p:nvSpPr>
@@ -6602,7 +6698,7 @@
       </p:sp>
       <p:sp>
         <p:nvSpPr>
-          <p:cNvPr id="22" name="Shape 19"/>
+          <p:cNvPr id="23" name="Shape 19"/>
           <p:cNvSpPr/>
           <p:nvPr/>
         </p:nvSpPr>
@@ -6627,7 +6723,7 @@
       </p:sp>
       <p:sp>
         <p:nvSpPr>
-          <p:cNvPr id="23" name="Text 20"/>
+          <p:cNvPr id="24" name="Text 20"/>
           <p:cNvSpPr/>
           <p:nvPr/>
         </p:nvSpPr>
@@ -6666,7 +6762,7 @@
       </p:sp>
       <p:sp>
         <p:nvSpPr>
-          <p:cNvPr id="24" name="Shape 21"/>
+          <p:cNvPr id="25" name="Shape 21"/>
           <p:cNvSpPr/>
           <p:nvPr/>
         </p:nvSpPr>
@@ -6691,7 +6787,7 @@
       </p:sp>
       <p:sp>
         <p:nvSpPr>
-          <p:cNvPr id="25" name="Text 22"/>
+          <p:cNvPr id="26" name="Text 22"/>
           <p:cNvSpPr/>
           <p:nvPr/>
         </p:nvSpPr>
@@ -6785,16 +6881,40 @@
           </a:ln>
         </p:spPr>
       </p:sp>
-      <p:sp>
-        <p:nvSpPr>
-          <p:cNvPr id="3" name="Text 1"/>
-          <p:cNvSpPr/>
-          <p:nvPr/>
-        </p:nvSpPr>
-        <p:spPr>
-          <a:xfrm>
-            <a:off x="365760" y="0"/>
-            <a:ext cx="8412480" cy="365760"/>
+      <p:pic>
+        <p:nvPicPr>
+          <p:cNvPr id="3" name="Image 0" descr="preencoded.png">    </p:cNvPr>
+          <p:cNvPicPr>
+            <a:picLocks noChangeAspect="1"/>
+          </p:cNvPicPr>
+          <p:nvPr/>
+        </p:nvPicPr>
+        <p:blipFill>
+          <a:blip r:embed="rId1"/>
+          <a:stretch>
+            <a:fillRect/>
+          </a:stretch>
+        </p:blipFill>
+        <p:spPr>
+          <a:xfrm>
+            <a:off x="91440" y="36576"/>
+            <a:ext cx="292608" cy="292608"/>
+          </a:xfrm>
+          <a:prstGeom prst="rect">
+            <a:avLst/>
+          </a:prstGeom>
+        </p:spPr>
+      </p:pic>
+      <p:sp>
+        <p:nvSpPr>
+          <p:cNvPr id="4" name="Text 1"/>
+          <p:cNvSpPr/>
+          <p:nvPr/>
+        </p:nvSpPr>
+        <p:spPr>
+          <a:xfrm>
+            <a:off x="457200" y="0"/>
+            <a:ext cx="8229600" cy="365760"/>
           </a:xfrm>
           <a:prstGeom prst="rect">
             <a:avLst/>
@@ -6818,7 +6938,7 @@
                 <a:ea typeface="Calibri" pitchFamily="34" charset="-122"/>
                 <a:cs typeface="Calibri" pitchFamily="34" charset="-120"/>
               </a:rPr>
-              <a:t>CSHSE · AI Import Wizard · User Guide</a:t>
+              <a:t>AI Import Wizard · User Guide</a:t>
             </a:r>
             <a:endParaRPr lang="en-US" sz="1000" dirty="0"/>
           </a:p>
@@ -6826,7 +6946,7 @@
       </p:sp>
       <p:sp>
         <p:nvSpPr>
-          <p:cNvPr id="4" name="Text 2"/>
+          <p:cNvPr id="5" name="Text 2"/>
           <p:cNvSpPr/>
           <p:nvPr/>
         </p:nvSpPr>
@@ -6865,7 +6985,7 @@
       </p:sp>
       <p:sp>
         <p:nvSpPr>
-          <p:cNvPr id="5" name="Text 3"/>
+          <p:cNvPr id="6" name="Text 3"/>
           <p:cNvSpPr/>
           <p:nvPr/>
         </p:nvSpPr>
@@ -6904,7 +7024,7 @@
       </p:sp>
       <p:sp>
         <p:nvSpPr>
-          <p:cNvPr id="6" name="Shape 4"/>
+          <p:cNvPr id="7" name="Shape 4"/>
           <p:cNvSpPr/>
           <p:nvPr/>
         </p:nvSpPr>
@@ -6936,14 +7056,14 @@
       </p:sp>
       <p:pic>
         <p:nvPicPr>
-          <p:cNvPr id="7" name="Image 0" descr="preencoded.png">    </p:cNvPr>
+          <p:cNvPr id="8" name="Image 1" descr="preencoded.png">    </p:cNvPr>
           <p:cNvPicPr>
             <a:picLocks noChangeAspect="1"/>
           </p:cNvPicPr>
           <p:nvPr/>
         </p:nvPicPr>
         <p:blipFill>
-          <a:blip r:embed="rId1"/>
+          <a:blip r:embed="rId2"/>
           <a:stretch>
             <a:fillRect/>
           </a:stretch>
@@ -6960,7 +7080,7 @@
       </p:pic>
       <p:sp>
         <p:nvSpPr>
-          <p:cNvPr id="8" name="Text 5"/>
+          <p:cNvPr id="9" name="Text 5"/>
           <p:cNvSpPr/>
           <p:nvPr/>
         </p:nvSpPr>
@@ -6999,7 +7119,7 @@
       </p:sp>
       <p:sp>
         <p:nvSpPr>
-          <p:cNvPr id="9" name="Text 6"/>
+          <p:cNvPr id="10" name="Text 6"/>
           <p:cNvSpPr/>
           <p:nvPr/>
         </p:nvSpPr>
@@ -7038,7 +7158,7 @@
       </p:sp>
       <p:sp>
         <p:nvSpPr>
-          <p:cNvPr id="10" name="Shape 7"/>
+          <p:cNvPr id="11" name="Shape 7"/>
           <p:cNvSpPr/>
           <p:nvPr/>
         </p:nvSpPr>
@@ -7070,14 +7190,14 @@
       </p:sp>
       <p:pic>
         <p:nvPicPr>
-          <p:cNvPr id="11" name="Image 1" descr="preencoded.png">    </p:cNvPr>
+          <p:cNvPr id="12" name="Image 2" descr="preencoded.png">    </p:cNvPr>
           <p:cNvPicPr>
             <a:picLocks noChangeAspect="1"/>
           </p:cNvPicPr>
           <p:nvPr/>
         </p:nvPicPr>
         <p:blipFill>
-          <a:blip r:embed="rId2"/>
+          <a:blip r:embed="rId3"/>
           <a:stretch>
             <a:fillRect/>
           </a:stretch>
@@ -7094,7 +7214,7 @@
       </p:pic>
       <p:sp>
         <p:nvSpPr>
-          <p:cNvPr id="12" name="Text 8"/>
+          <p:cNvPr id="13" name="Text 8"/>
           <p:cNvSpPr/>
           <p:nvPr/>
         </p:nvSpPr>
@@ -7133,7 +7253,7 @@
       </p:sp>
       <p:sp>
         <p:nvSpPr>
-          <p:cNvPr id="13" name="Text 9"/>
+          <p:cNvPr id="14" name="Text 9"/>
           <p:cNvSpPr/>
           <p:nvPr/>
         </p:nvSpPr>
@@ -7172,7 +7292,7 @@
       </p:sp>
       <p:sp>
         <p:nvSpPr>
-          <p:cNvPr id="14" name="Shape 10"/>
+          <p:cNvPr id="15" name="Shape 10"/>
           <p:cNvSpPr/>
           <p:nvPr/>
         </p:nvSpPr>
@@ -7204,14 +7324,14 @@
       </p:sp>
       <p:pic>
         <p:nvPicPr>
-          <p:cNvPr id="15" name="Image 2" descr="preencoded.png">    </p:cNvPr>
+          <p:cNvPr id="16" name="Image 3" descr="preencoded.png">    </p:cNvPr>
           <p:cNvPicPr>
             <a:picLocks noChangeAspect="1"/>
           </p:cNvPicPr>
           <p:nvPr/>
         </p:nvPicPr>
         <p:blipFill>
-          <a:blip r:embed="rId3"/>
+          <a:blip r:embed="rId4"/>
           <a:stretch>
             <a:fillRect/>
           </a:stretch>
@@ -7228,7 +7348,7 @@
       </p:pic>
       <p:sp>
         <p:nvSpPr>
-          <p:cNvPr id="16" name="Text 11"/>
+          <p:cNvPr id="17" name="Text 11"/>
           <p:cNvSpPr/>
           <p:nvPr/>
         </p:nvSpPr>
@@ -7267,7 +7387,7 @@
       </p:sp>
       <p:sp>
         <p:nvSpPr>
-          <p:cNvPr id="17" name="Text 12"/>
+          <p:cNvPr id="18" name="Text 12"/>
           <p:cNvSpPr/>
           <p:nvPr/>
         </p:nvSpPr>
@@ -7306,7 +7426,7 @@
       </p:sp>
       <p:sp>
         <p:nvSpPr>
-          <p:cNvPr id="18" name="Shape 13"/>
+          <p:cNvPr id="19" name="Shape 13"/>
           <p:cNvSpPr/>
           <p:nvPr/>
         </p:nvSpPr>
@@ -7338,14 +7458,14 @@
       </p:sp>
       <p:pic>
         <p:nvPicPr>
-          <p:cNvPr id="19" name="Image 3" descr="preencoded.png">    </p:cNvPr>
+          <p:cNvPr id="20" name="Image 4" descr="preencoded.png">    </p:cNvPr>
           <p:cNvPicPr>
             <a:picLocks noChangeAspect="1"/>
           </p:cNvPicPr>
           <p:nvPr/>
         </p:nvPicPr>
         <p:blipFill>
-          <a:blip r:embed="rId4"/>
+          <a:blip r:embed="rId5"/>
           <a:stretch>
             <a:fillRect/>
           </a:stretch>
@@ -7362,7 +7482,7 @@
       </p:pic>
       <p:sp>
         <p:nvSpPr>
-          <p:cNvPr id="20" name="Text 14"/>
+          <p:cNvPr id="21" name="Text 14"/>
           <p:cNvSpPr/>
           <p:nvPr/>
         </p:nvSpPr>
@@ -7401,7 +7521,7 @@
       </p:sp>
       <p:sp>
         <p:nvSpPr>
-          <p:cNvPr id="21" name="Text 15"/>
+          <p:cNvPr id="22" name="Text 15"/>
           <p:cNvSpPr/>
           <p:nvPr/>
         </p:nvSpPr>
@@ -7440,7 +7560,7 @@
       </p:sp>
       <p:sp>
         <p:nvSpPr>
-          <p:cNvPr id="22" name="Shape 16"/>
+          <p:cNvPr id="23" name="Shape 16"/>
           <p:cNvSpPr/>
           <p:nvPr/>
         </p:nvSpPr>
@@ -7465,7 +7585,7 @@
       </p:sp>
       <p:sp>
         <p:nvSpPr>
-          <p:cNvPr id="23" name="Text 17"/>
+          <p:cNvPr id="24" name="Text 17"/>
           <p:cNvSpPr/>
           <p:nvPr/>
         </p:nvSpPr>
@@ -7559,16 +7679,40 @@
           </a:ln>
         </p:spPr>
       </p:sp>
-      <p:sp>
-        <p:nvSpPr>
-          <p:cNvPr id="3" name="Text 1"/>
-          <p:cNvSpPr/>
-          <p:nvPr/>
-        </p:nvSpPr>
-        <p:spPr>
-          <a:xfrm>
-            <a:off x="365760" y="0"/>
-            <a:ext cx="8412480" cy="365760"/>
+      <p:pic>
+        <p:nvPicPr>
+          <p:cNvPr id="3" name="Image 0" descr="preencoded.png">    </p:cNvPr>
+          <p:cNvPicPr>
+            <a:picLocks noChangeAspect="1"/>
+          </p:cNvPicPr>
+          <p:nvPr/>
+        </p:nvPicPr>
+        <p:blipFill>
+          <a:blip r:embed="rId1"/>
+          <a:stretch>
+            <a:fillRect/>
+          </a:stretch>
+        </p:blipFill>
+        <p:spPr>
+          <a:xfrm>
+            <a:off x="91440" y="36576"/>
+            <a:ext cx="292608" cy="292608"/>
+          </a:xfrm>
+          <a:prstGeom prst="rect">
+            <a:avLst/>
+          </a:prstGeom>
+        </p:spPr>
+      </p:pic>
+      <p:sp>
+        <p:nvSpPr>
+          <p:cNvPr id="4" name="Text 1"/>
+          <p:cNvSpPr/>
+          <p:nvPr/>
+        </p:nvSpPr>
+        <p:spPr>
+          <a:xfrm>
+            <a:off x="457200" y="0"/>
+            <a:ext cx="8229600" cy="365760"/>
           </a:xfrm>
           <a:prstGeom prst="rect">
             <a:avLst/>
@@ -7592,7 +7736,7 @@
                 <a:ea typeface="Calibri" pitchFamily="34" charset="-122"/>
                 <a:cs typeface="Calibri" pitchFamily="34" charset="-120"/>
               </a:rPr>
-              <a:t>CSHSE · AI Import Wizard · User Guide</a:t>
+              <a:t>AI Import Wizard · User Guide</a:t>
             </a:r>
             <a:endParaRPr lang="en-US" sz="1000" dirty="0"/>
           </a:p>
@@ -7600,7 +7744,7 @@
       </p:sp>
       <p:sp>
         <p:nvSpPr>
-          <p:cNvPr id="4" name="Text 2"/>
+          <p:cNvPr id="5" name="Text 2"/>
           <p:cNvSpPr/>
           <p:nvPr/>
         </p:nvSpPr>
@@ -7639,7 +7783,7 @@
       </p:sp>
       <p:sp>
         <p:nvSpPr>
-          <p:cNvPr id="5" name="Text 3"/>
+          <p:cNvPr id="6" name="Text 3"/>
           <p:cNvSpPr/>
           <p:nvPr/>
         </p:nvSpPr>
@@ -7678,7 +7822,7 @@
       </p:sp>
       <p:sp>
         <p:nvSpPr>
-          <p:cNvPr id="6" name="Shape 4"/>
+          <p:cNvPr id="7" name="Shape 4"/>
           <p:cNvSpPr/>
           <p:nvPr/>
         </p:nvSpPr>
@@ -10311,7 +10455,7 @@
       </p:graphicFrame>
       <p:sp>
         <p:nvSpPr>
-          <p:cNvPr id="8" name="Shape 5"/>
+          <p:cNvPr id="9" name="Shape 5"/>
           <p:cNvSpPr/>
           <p:nvPr/>
         </p:nvSpPr>
@@ -10336,7 +10480,7 @@
       </p:sp>
       <p:sp>
         <p:nvSpPr>
-          <p:cNvPr id="9" name="Text 6"/>
+          <p:cNvPr id="10" name="Text 6"/>
           <p:cNvSpPr/>
           <p:nvPr/>
         </p:nvSpPr>
@@ -10430,16 +10574,40 @@
           </a:ln>
         </p:spPr>
       </p:sp>
-      <p:sp>
-        <p:nvSpPr>
-          <p:cNvPr id="3" name="Text 1"/>
-          <p:cNvSpPr/>
-          <p:nvPr/>
-        </p:nvSpPr>
-        <p:spPr>
-          <a:xfrm>
-            <a:off x="365760" y="0"/>
-            <a:ext cx="8412480" cy="365760"/>
+      <p:pic>
+        <p:nvPicPr>
+          <p:cNvPr id="3" name="Image 0" descr="preencoded.png">    </p:cNvPr>
+          <p:cNvPicPr>
+            <a:picLocks noChangeAspect="1"/>
+          </p:cNvPicPr>
+          <p:nvPr/>
+        </p:nvPicPr>
+        <p:blipFill>
+          <a:blip r:embed="rId1"/>
+          <a:stretch>
+            <a:fillRect/>
+          </a:stretch>
+        </p:blipFill>
+        <p:spPr>
+          <a:xfrm>
+            <a:off x="91440" y="36576"/>
+            <a:ext cx="292608" cy="292608"/>
+          </a:xfrm>
+          <a:prstGeom prst="rect">
+            <a:avLst/>
+          </a:prstGeom>
+        </p:spPr>
+      </p:pic>
+      <p:sp>
+        <p:nvSpPr>
+          <p:cNvPr id="4" name="Text 1"/>
+          <p:cNvSpPr/>
+          <p:nvPr/>
+        </p:nvSpPr>
+        <p:spPr>
+          <a:xfrm>
+            <a:off x="457200" y="0"/>
+            <a:ext cx="8229600" cy="365760"/>
           </a:xfrm>
           <a:prstGeom prst="rect">
             <a:avLst/>
@@ -10463,7 +10631,7 @@
                 <a:ea typeface="Calibri" pitchFamily="34" charset="-122"/>
                 <a:cs typeface="Calibri" pitchFamily="34" charset="-120"/>
               </a:rPr>
-              <a:t>CSHSE · AI Import Wizard · User Guide</a:t>
+              <a:t>AI Import Wizard · User Guide</a:t>
             </a:r>
             <a:endParaRPr lang="en-US" sz="1000" dirty="0"/>
           </a:p>
@@ -10471,7 +10639,7 @@
       </p:sp>
       <p:sp>
         <p:nvSpPr>
-          <p:cNvPr id="4" name="Text 2"/>
+          <p:cNvPr id="5" name="Text 2"/>
           <p:cNvSpPr/>
           <p:nvPr/>
         </p:nvSpPr>
@@ -10510,7 +10678,7 @@
       </p:sp>
       <p:sp>
         <p:nvSpPr>
-          <p:cNvPr id="5" name="Text 3"/>
+          <p:cNvPr id="6" name="Text 3"/>
           <p:cNvSpPr/>
           <p:nvPr/>
         </p:nvSpPr>
@@ -10549,7 +10717,7 @@
       </p:sp>
       <p:sp>
         <p:nvSpPr>
-          <p:cNvPr id="6" name="Shape 4"/>
+          <p:cNvPr id="7" name="Shape 4"/>
           <p:cNvSpPr/>
           <p:nvPr/>
         </p:nvSpPr>
@@ -10581,14 +10749,14 @@
       </p:sp>
       <p:pic>
         <p:nvPicPr>
-          <p:cNvPr id="7" name="Image 0" descr="preencoded.png">    </p:cNvPr>
+          <p:cNvPr id="8" name="Image 1" descr="preencoded.png">    </p:cNvPr>
           <p:cNvPicPr>
             <a:picLocks noChangeAspect="1"/>
           </p:cNvPicPr>
           <p:nvPr/>
         </p:nvPicPr>
         <p:blipFill>
-          <a:blip r:embed="rId1"/>
+          <a:blip r:embed="rId2"/>
           <a:stretch>
             <a:fillRect/>
           </a:stretch>
@@ -10605,7 +10773,7 @@
       </p:pic>
       <p:sp>
         <p:nvSpPr>
-          <p:cNvPr id="8" name="Text 5"/>
+          <p:cNvPr id="9" name="Text 5"/>
           <p:cNvSpPr/>
           <p:nvPr/>
         </p:nvSpPr>
@@ -10644,7 +10812,7 @@
       </p:sp>
       <p:sp>
         <p:nvSpPr>
-          <p:cNvPr id="9" name="Text 6"/>
+          <p:cNvPr id="10" name="Text 6"/>
           <p:cNvSpPr/>
           <p:nvPr/>
         </p:nvSpPr>
@@ -10683,7 +10851,7 @@
       </p:sp>
       <p:sp>
         <p:nvSpPr>
-          <p:cNvPr id="10" name="Shape 7"/>
+          <p:cNvPr id="11" name="Shape 7"/>
           <p:cNvSpPr/>
           <p:nvPr/>
         </p:nvSpPr>
@@ -10715,14 +10883,14 @@
       </p:sp>
       <p:pic>
         <p:nvPicPr>
-          <p:cNvPr id="11" name="Image 1" descr="preencoded.png">    </p:cNvPr>
+          <p:cNvPr id="12" name="Image 2" descr="preencoded.png">    </p:cNvPr>
           <p:cNvPicPr>
             <a:picLocks noChangeAspect="1"/>
           </p:cNvPicPr>
           <p:nvPr/>
         </p:nvPicPr>
         <p:blipFill>
-          <a:blip r:embed="rId2"/>
+          <a:blip r:embed="rId3"/>
           <a:stretch>
             <a:fillRect/>
           </a:stretch>
@@ -10739,7 +10907,7 @@
       </p:pic>
       <p:sp>
         <p:nvSpPr>
-          <p:cNvPr id="12" name="Text 8"/>
+          <p:cNvPr id="13" name="Text 8"/>
           <p:cNvSpPr/>
           <p:nvPr/>
         </p:nvSpPr>
@@ -10778,7 +10946,7 @@
       </p:sp>
       <p:sp>
         <p:nvSpPr>
-          <p:cNvPr id="13" name="Text 9"/>
+          <p:cNvPr id="14" name="Text 9"/>
           <p:cNvSpPr/>
           <p:nvPr/>
         </p:nvSpPr>
@@ -10817,7 +10985,7 @@
       </p:sp>
       <p:sp>
         <p:nvSpPr>
-          <p:cNvPr id="14" name="Shape 10"/>
+          <p:cNvPr id="15" name="Shape 10"/>
           <p:cNvSpPr/>
           <p:nvPr/>
         </p:nvSpPr>
@@ -10849,14 +11017,14 @@
       </p:sp>
       <p:pic>
         <p:nvPicPr>
-          <p:cNvPr id="15" name="Image 2" descr="preencoded.png">    </p:cNvPr>
+          <p:cNvPr id="16" name="Image 3" descr="preencoded.png">    </p:cNvPr>
           <p:cNvPicPr>
             <a:picLocks noChangeAspect="1"/>
           </p:cNvPicPr>
           <p:nvPr/>
         </p:nvPicPr>
         <p:blipFill>
-          <a:blip r:embed="rId3"/>
+          <a:blip r:embed="rId4"/>
           <a:stretch>
             <a:fillRect/>
           </a:stretch>
@@ -10873,7 +11041,7 @@
       </p:pic>
       <p:sp>
         <p:nvSpPr>
-          <p:cNvPr id="16" name="Text 11"/>
+          <p:cNvPr id="17" name="Text 11"/>
           <p:cNvSpPr/>
           <p:nvPr/>
         </p:nvSpPr>
@@ -10912,7 +11080,7 @@
       </p:sp>
       <p:sp>
         <p:nvSpPr>
-          <p:cNvPr id="17" name="Text 12"/>
+          <p:cNvPr id="18" name="Text 12"/>
           <p:cNvSpPr/>
           <p:nvPr/>
         </p:nvSpPr>
@@ -10951,7 +11119,7 @@
       </p:sp>
       <p:sp>
         <p:nvSpPr>
-          <p:cNvPr id="18" name="Shape 13"/>
+          <p:cNvPr id="19" name="Shape 13"/>
           <p:cNvSpPr/>
           <p:nvPr/>
         </p:nvSpPr>
@@ -10983,14 +11151,14 @@
       </p:sp>
       <p:pic>
         <p:nvPicPr>
-          <p:cNvPr id="19" name="Image 3" descr="preencoded.png">    </p:cNvPr>
+          <p:cNvPr id="20" name="Image 4" descr="preencoded.png">    </p:cNvPr>
           <p:cNvPicPr>
             <a:picLocks noChangeAspect="1"/>
           </p:cNvPicPr>
           <p:nvPr/>
         </p:nvPicPr>
         <p:blipFill>
-          <a:blip r:embed="rId4"/>
+          <a:blip r:embed="rId5"/>
           <a:stretch>
             <a:fillRect/>
           </a:stretch>
@@ -11007,7 +11175,7 @@
       </p:pic>
       <p:sp>
         <p:nvSpPr>
-          <p:cNvPr id="20" name="Text 14"/>
+          <p:cNvPr id="21" name="Text 14"/>
           <p:cNvSpPr/>
           <p:nvPr/>
         </p:nvSpPr>
@@ -11046,7 +11214,7 @@
       </p:sp>
       <p:sp>
         <p:nvSpPr>
-          <p:cNvPr id="21" name="Text 15"/>
+          <p:cNvPr id="22" name="Text 15"/>
           <p:cNvSpPr/>
           <p:nvPr/>
         </p:nvSpPr>
@@ -11085,7 +11253,7 @@
       </p:sp>
       <p:sp>
         <p:nvSpPr>
-          <p:cNvPr id="22" name="Shape 16"/>
+          <p:cNvPr id="23" name="Shape 16"/>
           <p:cNvSpPr/>
           <p:nvPr/>
         </p:nvSpPr>
@@ -11117,14 +11285,14 @@
       </p:sp>
       <p:pic>
         <p:nvPicPr>
-          <p:cNvPr id="23" name="Image 4" descr="preencoded.png">    </p:cNvPr>
+          <p:cNvPr id="24" name="Image 5" descr="preencoded.png">    </p:cNvPr>
           <p:cNvPicPr>
             <a:picLocks noChangeAspect="1"/>
           </p:cNvPicPr>
           <p:nvPr/>
         </p:nvPicPr>
         <p:blipFill>
-          <a:blip r:embed="rId5"/>
+          <a:blip r:embed="rId6"/>
           <a:stretch>
             <a:fillRect/>
           </a:stretch>
@@ -11141,7 +11309,7 @@
       </p:pic>
       <p:sp>
         <p:nvSpPr>
-          <p:cNvPr id="24" name="Text 17"/>
+          <p:cNvPr id="25" name="Text 17"/>
           <p:cNvSpPr/>
           <p:nvPr/>
         </p:nvSpPr>
@@ -11180,7 +11348,7 @@
       </p:sp>
       <p:sp>
         <p:nvSpPr>
-          <p:cNvPr id="25" name="Text 18"/>
+          <p:cNvPr id="26" name="Text 18"/>
           <p:cNvSpPr/>
           <p:nvPr/>
         </p:nvSpPr>
@@ -11219,7 +11387,7 @@
       </p:sp>
       <p:sp>
         <p:nvSpPr>
-          <p:cNvPr id="26" name="Shape 19"/>
+          <p:cNvPr id="27" name="Shape 19"/>
           <p:cNvSpPr/>
           <p:nvPr/>
         </p:nvSpPr>
@@ -11244,7 +11412,7 @@
       </p:sp>
       <p:sp>
         <p:nvSpPr>
-          <p:cNvPr id="27" name="Text 20"/>
+          <p:cNvPr id="28" name="Text 20"/>
           <p:cNvSpPr/>
           <p:nvPr/>
         </p:nvSpPr>
@@ -11383,8 +11551,8 @@
         </p:blipFill>
         <p:spPr>
           <a:xfrm>
-            <a:off x="731520" y="914400"/>
-            <a:ext cx="822960" cy="822960"/>
+            <a:off x="731520" y="548640"/>
+            <a:ext cx="1188720" cy="1188720"/>
           </a:xfrm>
           <a:prstGeom prst="rect">
             <a:avLst/>
@@ -11399,8 +11567,8 @@
         </p:nvSpPr>
         <p:spPr>
           <a:xfrm>
-            <a:off x="731520" y="1828800"/>
-            <a:ext cx="4114800" cy="640080"/>
+            <a:off x="457200" y="1828800"/>
+            <a:ext cx="4297680" cy="640080"/>
           </a:xfrm>
           <a:prstGeom prst="rect">
             <a:avLst/>
@@ -11438,8 +11606,8 @@
         </p:nvSpPr>
         <p:spPr>
           <a:xfrm>
-            <a:off x="731520" y="2514600"/>
-            <a:ext cx="4114800" cy="365760"/>
+            <a:off x="457200" y="2514600"/>
+            <a:ext cx="4297680" cy="365760"/>
           </a:xfrm>
           <a:prstGeom prst="rect">
             <a:avLst/>
@@ -11621,16 +11789,40 @@
           </a:ln>
         </p:spPr>
       </p:sp>
-      <p:sp>
-        <p:nvSpPr>
-          <p:cNvPr id="3" name="Text 1"/>
-          <p:cNvSpPr/>
-          <p:nvPr/>
-        </p:nvSpPr>
-        <p:spPr>
-          <a:xfrm>
-            <a:off x="365760" y="0"/>
-            <a:ext cx="8412480" cy="365760"/>
+      <p:pic>
+        <p:nvPicPr>
+          <p:cNvPr id="3" name="Image 0" descr="preencoded.png">    </p:cNvPr>
+          <p:cNvPicPr>
+            <a:picLocks noChangeAspect="1"/>
+          </p:cNvPicPr>
+          <p:nvPr/>
+        </p:nvPicPr>
+        <p:blipFill>
+          <a:blip r:embed="rId1"/>
+          <a:stretch>
+            <a:fillRect/>
+          </a:stretch>
+        </p:blipFill>
+        <p:spPr>
+          <a:xfrm>
+            <a:off x="91440" y="36576"/>
+            <a:ext cx="292608" cy="292608"/>
+          </a:xfrm>
+          <a:prstGeom prst="rect">
+            <a:avLst/>
+          </a:prstGeom>
+        </p:spPr>
+      </p:pic>
+      <p:sp>
+        <p:nvSpPr>
+          <p:cNvPr id="4" name="Text 1"/>
+          <p:cNvSpPr/>
+          <p:nvPr/>
+        </p:nvSpPr>
+        <p:spPr>
+          <a:xfrm>
+            <a:off x="457200" y="0"/>
+            <a:ext cx="8229600" cy="365760"/>
           </a:xfrm>
           <a:prstGeom prst="rect">
             <a:avLst/>
@@ -11654,7 +11846,7 @@
                 <a:ea typeface="Calibri" pitchFamily="34" charset="-122"/>
                 <a:cs typeface="Calibri" pitchFamily="34" charset="-120"/>
               </a:rPr>
-              <a:t>CSHSE · AI Import Wizard · User Guide</a:t>
+              <a:t>AI Import Wizard · User Guide</a:t>
             </a:r>
             <a:endParaRPr lang="en-US" sz="1000" dirty="0"/>
           </a:p>
@@ -11662,7 +11854,7 @@
       </p:sp>
       <p:sp>
         <p:nvSpPr>
-          <p:cNvPr id="4" name="Text 2"/>
+          <p:cNvPr id="5" name="Text 2"/>
           <p:cNvSpPr/>
           <p:nvPr/>
         </p:nvSpPr>
@@ -11701,7 +11893,7 @@
       </p:sp>
       <p:sp>
         <p:nvSpPr>
-          <p:cNvPr id="5" name="Text 3"/>
+          <p:cNvPr id="6" name="Text 3"/>
           <p:cNvSpPr/>
           <p:nvPr/>
         </p:nvSpPr>
@@ -11740,7 +11932,7 @@
       </p:sp>
       <p:sp>
         <p:nvSpPr>
-          <p:cNvPr id="6" name="Shape 4"/>
+          <p:cNvPr id="7" name="Shape 4"/>
           <p:cNvSpPr/>
           <p:nvPr/>
         </p:nvSpPr>
@@ -11772,7 +11964,7 @@
       </p:sp>
       <p:sp>
         <p:nvSpPr>
-          <p:cNvPr id="7" name="Shape 5"/>
+          <p:cNvPr id="8" name="Shape 5"/>
           <p:cNvSpPr/>
           <p:nvPr/>
         </p:nvSpPr>
@@ -11797,7 +11989,7 @@
       </p:sp>
       <p:sp>
         <p:nvSpPr>
-          <p:cNvPr id="8" name="Text 6"/>
+          <p:cNvPr id="9" name="Text 6"/>
           <p:cNvSpPr/>
           <p:nvPr/>
         </p:nvSpPr>
@@ -11836,7 +12028,7 @@
       </p:sp>
       <p:sp>
         <p:nvSpPr>
-          <p:cNvPr id="9" name="Text 7"/>
+          <p:cNvPr id="10" name="Text 7"/>
           <p:cNvSpPr/>
           <p:nvPr/>
         </p:nvSpPr>
@@ -11983,14 +12175,14 @@
       </p:sp>
       <p:pic>
         <p:nvPicPr>
-          <p:cNvPr id="10" name="Image 0" descr="preencoded.png">    </p:cNvPr>
+          <p:cNvPr id="11" name="Image 1" descr="preencoded.png">    </p:cNvPr>
           <p:cNvPicPr>
             <a:picLocks noChangeAspect="1"/>
           </p:cNvPicPr>
           <p:nvPr/>
         </p:nvPicPr>
         <p:blipFill>
-          <a:blip r:embed="rId1"/>
+          <a:blip r:embed="rId2"/>
           <a:stretch>
             <a:fillRect/>
           </a:stretch>
@@ -12007,7 +12199,7 @@
       </p:pic>
       <p:sp>
         <p:nvSpPr>
-          <p:cNvPr id="11" name="Shape 8"/>
+          <p:cNvPr id="12" name="Shape 8"/>
           <p:cNvSpPr/>
           <p:nvPr/>
         </p:nvSpPr>
@@ -12039,7 +12231,7 @@
       </p:sp>
       <p:sp>
         <p:nvSpPr>
-          <p:cNvPr id="12" name="Shape 9"/>
+          <p:cNvPr id="13" name="Shape 9"/>
           <p:cNvSpPr/>
           <p:nvPr/>
         </p:nvSpPr>
@@ -12064,7 +12256,7 @@
       </p:sp>
       <p:sp>
         <p:nvSpPr>
-          <p:cNvPr id="13" name="Text 10"/>
+          <p:cNvPr id="14" name="Text 10"/>
           <p:cNvSpPr/>
           <p:nvPr/>
         </p:nvSpPr>
@@ -12103,7 +12295,7 @@
       </p:sp>
       <p:sp>
         <p:nvSpPr>
-          <p:cNvPr id="14" name="Text 11"/>
+          <p:cNvPr id="15" name="Text 11"/>
           <p:cNvSpPr/>
           <p:nvPr/>
         </p:nvSpPr>
@@ -12250,7 +12442,7 @@
       </p:sp>
       <p:sp>
         <p:nvSpPr>
-          <p:cNvPr id="15" name="Shape 12"/>
+          <p:cNvPr id="16" name="Shape 12"/>
           <p:cNvSpPr/>
           <p:nvPr/>
         </p:nvSpPr>
@@ -12275,7 +12467,7 @@
       </p:sp>
       <p:sp>
         <p:nvSpPr>
-          <p:cNvPr id="16" name="Text 13"/>
+          <p:cNvPr id="17" name="Text 13"/>
           <p:cNvSpPr/>
           <p:nvPr/>
         </p:nvSpPr>
@@ -12369,16 +12561,40 @@
           </a:ln>
         </p:spPr>
       </p:sp>
-      <p:sp>
-        <p:nvSpPr>
-          <p:cNvPr id="3" name="Text 1"/>
-          <p:cNvSpPr/>
-          <p:nvPr/>
-        </p:nvSpPr>
-        <p:spPr>
-          <a:xfrm>
-            <a:off x="365760" y="0"/>
-            <a:ext cx="8412480" cy="365760"/>
+      <p:pic>
+        <p:nvPicPr>
+          <p:cNvPr id="3" name="Image 0" descr="preencoded.png">    </p:cNvPr>
+          <p:cNvPicPr>
+            <a:picLocks noChangeAspect="1"/>
+          </p:cNvPicPr>
+          <p:nvPr/>
+        </p:nvPicPr>
+        <p:blipFill>
+          <a:blip r:embed="rId1"/>
+          <a:stretch>
+            <a:fillRect/>
+          </a:stretch>
+        </p:blipFill>
+        <p:spPr>
+          <a:xfrm>
+            <a:off x="91440" y="36576"/>
+            <a:ext cx="292608" cy="292608"/>
+          </a:xfrm>
+          <a:prstGeom prst="rect">
+            <a:avLst/>
+          </a:prstGeom>
+        </p:spPr>
+      </p:pic>
+      <p:sp>
+        <p:nvSpPr>
+          <p:cNvPr id="4" name="Text 1"/>
+          <p:cNvSpPr/>
+          <p:nvPr/>
+        </p:nvSpPr>
+        <p:spPr>
+          <a:xfrm>
+            <a:off x="457200" y="0"/>
+            <a:ext cx="8229600" cy="365760"/>
           </a:xfrm>
           <a:prstGeom prst="rect">
             <a:avLst/>
@@ -12402,7 +12618,7 @@
                 <a:ea typeface="Calibri" pitchFamily="34" charset="-122"/>
                 <a:cs typeface="Calibri" pitchFamily="34" charset="-120"/>
               </a:rPr>
-              <a:t>CSHSE · AI Import Wizard · User Guide</a:t>
+              <a:t>AI Import Wizard · User Guide</a:t>
             </a:r>
             <a:endParaRPr lang="en-US" sz="1000" dirty="0"/>
           </a:p>
@@ -12410,7 +12626,7 @@
       </p:sp>
       <p:sp>
         <p:nvSpPr>
-          <p:cNvPr id="4" name="Text 2"/>
+          <p:cNvPr id="5" name="Text 2"/>
           <p:cNvSpPr/>
           <p:nvPr/>
         </p:nvSpPr>
@@ -12449,7 +12665,7 @@
       </p:sp>
       <p:sp>
         <p:nvSpPr>
-          <p:cNvPr id="5" name="Text 3"/>
+          <p:cNvPr id="6" name="Text 3"/>
           <p:cNvSpPr/>
           <p:nvPr/>
         </p:nvSpPr>
@@ -12488,7 +12704,7 @@
       </p:sp>
       <p:sp>
         <p:nvSpPr>
-          <p:cNvPr id="6" name="Shape 4"/>
+          <p:cNvPr id="7" name="Shape 4"/>
           <p:cNvSpPr/>
           <p:nvPr/>
         </p:nvSpPr>
@@ -12520,14 +12736,14 @@
       </p:sp>
       <p:pic>
         <p:nvPicPr>
-          <p:cNvPr id="7" name="Image 0" descr="preencoded.png">    </p:cNvPr>
+          <p:cNvPr id="8" name="Image 1" descr="preencoded.png">    </p:cNvPr>
           <p:cNvPicPr>
             <a:picLocks noChangeAspect="1"/>
           </p:cNvPicPr>
           <p:nvPr/>
         </p:nvPicPr>
         <p:blipFill>
-          <a:blip r:embed="rId1"/>
+          <a:blip r:embed="rId2"/>
           <a:stretch>
             <a:fillRect/>
           </a:stretch>
@@ -12544,7 +12760,7 @@
       </p:pic>
       <p:sp>
         <p:nvSpPr>
-          <p:cNvPr id="8" name="Text 5"/>
+          <p:cNvPr id="9" name="Text 5"/>
           <p:cNvSpPr/>
           <p:nvPr/>
         </p:nvSpPr>
@@ -12583,7 +12799,7 @@
       </p:sp>
       <p:sp>
         <p:nvSpPr>
-          <p:cNvPr id="9" name="Text 6"/>
+          <p:cNvPr id="10" name="Text 6"/>
           <p:cNvSpPr/>
           <p:nvPr/>
         </p:nvSpPr>
@@ -12622,7 +12838,7 @@
       </p:sp>
       <p:sp>
         <p:nvSpPr>
-          <p:cNvPr id="10" name="Shape 7"/>
+          <p:cNvPr id="11" name="Shape 7"/>
           <p:cNvSpPr/>
           <p:nvPr/>
         </p:nvSpPr>
@@ -12654,14 +12870,14 @@
       </p:sp>
       <p:pic>
         <p:nvPicPr>
-          <p:cNvPr id="11" name="Image 1" descr="preencoded.png">    </p:cNvPr>
+          <p:cNvPr id="12" name="Image 2" descr="preencoded.png">    </p:cNvPr>
           <p:cNvPicPr>
             <a:picLocks noChangeAspect="1"/>
           </p:cNvPicPr>
           <p:nvPr/>
         </p:nvPicPr>
         <p:blipFill>
-          <a:blip r:embed="rId2"/>
+          <a:blip r:embed="rId3"/>
           <a:stretch>
             <a:fillRect/>
           </a:stretch>
@@ -12678,7 +12894,7 @@
       </p:pic>
       <p:sp>
         <p:nvSpPr>
-          <p:cNvPr id="12" name="Text 8"/>
+          <p:cNvPr id="13" name="Text 8"/>
           <p:cNvSpPr/>
           <p:nvPr/>
         </p:nvSpPr>
@@ -12717,7 +12933,7 @@
       </p:sp>
       <p:sp>
         <p:nvSpPr>
-          <p:cNvPr id="13" name="Text 9"/>
+          <p:cNvPr id="14" name="Text 9"/>
           <p:cNvSpPr/>
           <p:nvPr/>
         </p:nvSpPr>
@@ -12756,7 +12972,7 @@
       </p:sp>
       <p:sp>
         <p:nvSpPr>
-          <p:cNvPr id="14" name="Shape 10"/>
+          <p:cNvPr id="15" name="Shape 10"/>
           <p:cNvSpPr/>
           <p:nvPr/>
         </p:nvSpPr>
@@ -12788,14 +13004,14 @@
       </p:sp>
       <p:pic>
         <p:nvPicPr>
-          <p:cNvPr id="15" name="Image 2" descr="preencoded.png">    </p:cNvPr>
+          <p:cNvPr id="16" name="Image 3" descr="preencoded.png">    </p:cNvPr>
           <p:cNvPicPr>
             <a:picLocks noChangeAspect="1"/>
           </p:cNvPicPr>
           <p:nvPr/>
         </p:nvPicPr>
         <p:blipFill>
-          <a:blip r:embed="rId3"/>
+          <a:blip r:embed="rId4"/>
           <a:stretch>
             <a:fillRect/>
           </a:stretch>
@@ -12812,7 +13028,7 @@
       </p:pic>
       <p:sp>
         <p:nvSpPr>
-          <p:cNvPr id="16" name="Text 11"/>
+          <p:cNvPr id="17" name="Text 11"/>
           <p:cNvSpPr/>
           <p:nvPr/>
         </p:nvSpPr>
@@ -12851,7 +13067,7 @@
       </p:sp>
       <p:sp>
         <p:nvSpPr>
-          <p:cNvPr id="17" name="Text 12"/>
+          <p:cNvPr id="18" name="Text 12"/>
           <p:cNvSpPr/>
           <p:nvPr/>
         </p:nvSpPr>
@@ -12890,7 +13106,7 @@
       </p:sp>
       <p:sp>
         <p:nvSpPr>
-          <p:cNvPr id="18" name="Shape 13"/>
+          <p:cNvPr id="19" name="Shape 13"/>
           <p:cNvSpPr/>
           <p:nvPr/>
         </p:nvSpPr>
@@ -12922,14 +13138,14 @@
       </p:sp>
       <p:pic>
         <p:nvPicPr>
-          <p:cNvPr id="19" name="Image 3" descr="preencoded.png">    </p:cNvPr>
+          <p:cNvPr id="20" name="Image 4" descr="preencoded.png">    </p:cNvPr>
           <p:cNvPicPr>
             <a:picLocks noChangeAspect="1"/>
           </p:cNvPicPr>
           <p:nvPr/>
         </p:nvPicPr>
         <p:blipFill>
-          <a:blip r:embed="rId4"/>
+          <a:blip r:embed="rId5"/>
           <a:stretch>
             <a:fillRect/>
           </a:stretch>
@@ -12946,7 +13162,7 @@
       </p:pic>
       <p:sp>
         <p:nvSpPr>
-          <p:cNvPr id="20" name="Text 14"/>
+          <p:cNvPr id="21" name="Text 14"/>
           <p:cNvSpPr/>
           <p:nvPr/>
         </p:nvSpPr>
@@ -12985,7 +13201,7 @@
       </p:sp>
       <p:sp>
         <p:nvSpPr>
-          <p:cNvPr id="21" name="Text 15"/>
+          <p:cNvPr id="22" name="Text 15"/>
           <p:cNvSpPr/>
           <p:nvPr/>
         </p:nvSpPr>
@@ -13024,7 +13240,7 @@
       </p:sp>
       <p:sp>
         <p:nvSpPr>
-          <p:cNvPr id="22" name="Shape 16"/>
+          <p:cNvPr id="23" name="Shape 16"/>
           <p:cNvSpPr/>
           <p:nvPr/>
         </p:nvSpPr>
@@ -13056,14 +13272,14 @@
       </p:sp>
       <p:pic>
         <p:nvPicPr>
-          <p:cNvPr id="23" name="Image 4" descr="preencoded.png">    </p:cNvPr>
+          <p:cNvPr id="24" name="Image 5" descr="preencoded.png">    </p:cNvPr>
           <p:cNvPicPr>
             <a:picLocks noChangeAspect="1"/>
           </p:cNvPicPr>
           <p:nvPr/>
         </p:nvPicPr>
         <p:blipFill>
-          <a:blip r:embed="rId5"/>
+          <a:blip r:embed="rId6"/>
           <a:stretch>
             <a:fillRect/>
           </a:stretch>
@@ -13080,7 +13296,7 @@
       </p:pic>
       <p:sp>
         <p:nvSpPr>
-          <p:cNvPr id="24" name="Text 17"/>
+          <p:cNvPr id="25" name="Text 17"/>
           <p:cNvSpPr/>
           <p:nvPr/>
         </p:nvSpPr>
@@ -13119,7 +13335,7 @@
       </p:sp>
       <p:sp>
         <p:nvSpPr>
-          <p:cNvPr id="25" name="Text 18"/>
+          <p:cNvPr id="26" name="Text 18"/>
           <p:cNvSpPr/>
           <p:nvPr/>
         </p:nvSpPr>
@@ -13158,7 +13374,7 @@
       </p:sp>
       <p:sp>
         <p:nvSpPr>
-          <p:cNvPr id="26" name="Shape 19"/>
+          <p:cNvPr id="27" name="Shape 19"/>
           <p:cNvSpPr/>
           <p:nvPr/>
         </p:nvSpPr>
@@ -13183,7 +13399,7 @@
       </p:sp>
       <p:sp>
         <p:nvSpPr>
-          <p:cNvPr id="27" name="Shape 20"/>
+          <p:cNvPr id="28" name="Shape 20"/>
           <p:cNvSpPr/>
           <p:nvPr/>
         </p:nvSpPr>
@@ -13208,7 +13424,7 @@
       </p:sp>
       <p:sp>
         <p:nvSpPr>
-          <p:cNvPr id="28" name="Shape 21"/>
+          <p:cNvPr id="29" name="Shape 21"/>
           <p:cNvSpPr/>
           <p:nvPr/>
         </p:nvSpPr>
@@ -13233,7 +13449,7 @@
       </p:sp>
       <p:sp>
         <p:nvSpPr>
-          <p:cNvPr id="29" name="Text 22"/>
+          <p:cNvPr id="30" name="Text 22"/>
           <p:cNvSpPr/>
           <p:nvPr/>
         </p:nvSpPr>
@@ -13272,7 +13488,7 @@
       </p:sp>
       <p:sp>
         <p:nvSpPr>
-          <p:cNvPr id="30" name="Text 23"/>
+          <p:cNvPr id="31" name="Text 23"/>
           <p:cNvSpPr/>
           <p:nvPr/>
         </p:nvSpPr>
@@ -13311,7 +13527,7 @@
       </p:sp>
       <p:sp>
         <p:nvSpPr>
-          <p:cNvPr id="31" name="Shape 24"/>
+          <p:cNvPr id="32" name="Shape 24"/>
           <p:cNvSpPr/>
           <p:nvPr/>
         </p:nvSpPr>
@@ -13336,7 +13552,7 @@
       </p:sp>
       <p:sp>
         <p:nvSpPr>
-          <p:cNvPr id="32" name="Text 25"/>
+          <p:cNvPr id="33" name="Text 25"/>
           <p:cNvSpPr/>
           <p:nvPr/>
         </p:nvSpPr>
@@ -13430,16 +13646,40 @@
           </a:ln>
         </p:spPr>
       </p:sp>
-      <p:sp>
-        <p:nvSpPr>
-          <p:cNvPr id="3" name="Text 1"/>
-          <p:cNvSpPr/>
-          <p:nvPr/>
-        </p:nvSpPr>
-        <p:spPr>
-          <a:xfrm>
-            <a:off x="365760" y="0"/>
-            <a:ext cx="8412480" cy="365760"/>
+      <p:pic>
+        <p:nvPicPr>
+          <p:cNvPr id="3" name="Image 0" descr="preencoded.png">    </p:cNvPr>
+          <p:cNvPicPr>
+            <a:picLocks noChangeAspect="1"/>
+          </p:cNvPicPr>
+          <p:nvPr/>
+        </p:nvPicPr>
+        <p:blipFill>
+          <a:blip r:embed="rId1"/>
+          <a:stretch>
+            <a:fillRect/>
+          </a:stretch>
+        </p:blipFill>
+        <p:spPr>
+          <a:xfrm>
+            <a:off x="91440" y="36576"/>
+            <a:ext cx="292608" cy="292608"/>
+          </a:xfrm>
+          <a:prstGeom prst="rect">
+            <a:avLst/>
+          </a:prstGeom>
+        </p:spPr>
+      </p:pic>
+      <p:sp>
+        <p:nvSpPr>
+          <p:cNvPr id="4" name="Text 1"/>
+          <p:cNvSpPr/>
+          <p:nvPr/>
+        </p:nvSpPr>
+        <p:spPr>
+          <a:xfrm>
+            <a:off x="457200" y="0"/>
+            <a:ext cx="8229600" cy="365760"/>
           </a:xfrm>
           <a:prstGeom prst="rect">
             <a:avLst/>
@@ -13463,7 +13703,7 @@
                 <a:ea typeface="Calibri" pitchFamily="34" charset="-122"/>
                 <a:cs typeface="Calibri" pitchFamily="34" charset="-120"/>
               </a:rPr>
-              <a:t>CSHSE · AI Import Wizard · User Guide</a:t>
+              <a:t>AI Import Wizard · User Guide</a:t>
             </a:r>
             <a:endParaRPr lang="en-US" sz="1000" dirty="0"/>
           </a:p>
@@ -13471,7 +13711,7 @@
       </p:sp>
       <p:sp>
         <p:nvSpPr>
-          <p:cNvPr id="4" name="Text 2"/>
+          <p:cNvPr id="5" name="Text 2"/>
           <p:cNvSpPr/>
           <p:nvPr/>
         </p:nvSpPr>
@@ -13510,7 +13750,7 @@
       </p:sp>
       <p:sp>
         <p:nvSpPr>
-          <p:cNvPr id="5" name="Text 3"/>
+          <p:cNvPr id="6" name="Text 3"/>
           <p:cNvSpPr/>
           <p:nvPr/>
         </p:nvSpPr>
@@ -13549,7 +13789,7 @@
       </p:sp>
       <p:sp>
         <p:nvSpPr>
-          <p:cNvPr id="6" name="Shape 4"/>
+          <p:cNvPr id="7" name="Shape 4"/>
           <p:cNvSpPr/>
           <p:nvPr/>
         </p:nvSpPr>
@@ -13581,14 +13821,14 @@
       </p:sp>
       <p:pic>
         <p:nvPicPr>
-          <p:cNvPr id="7" name="Image 0" descr="preencoded.png">    </p:cNvPr>
+          <p:cNvPr id="8" name="Image 1" descr="preencoded.png">    </p:cNvPr>
           <p:cNvPicPr>
             <a:picLocks noChangeAspect="1"/>
           </p:cNvPicPr>
           <p:nvPr/>
         </p:nvPicPr>
         <p:blipFill>
-          <a:blip r:embed="rId1"/>
+          <a:blip r:embed="rId2"/>
           <a:stretch>
             <a:fillRect/>
           </a:stretch>
@@ -13605,7 +13845,7 @@
       </p:pic>
       <p:sp>
         <p:nvSpPr>
-          <p:cNvPr id="8" name="Text 5"/>
+          <p:cNvPr id="9" name="Text 5"/>
           <p:cNvSpPr/>
           <p:nvPr/>
         </p:nvSpPr>
@@ -13644,7 +13884,7 @@
       </p:sp>
       <p:sp>
         <p:nvSpPr>
-          <p:cNvPr id="9" name="Text 6"/>
+          <p:cNvPr id="10" name="Text 6"/>
           <p:cNvSpPr/>
           <p:nvPr/>
         </p:nvSpPr>
@@ -13683,7 +13923,7 @@
       </p:sp>
       <p:sp>
         <p:nvSpPr>
-          <p:cNvPr id="10" name="Shape 7"/>
+          <p:cNvPr id="11" name="Shape 7"/>
           <p:cNvSpPr/>
           <p:nvPr/>
         </p:nvSpPr>
@@ -13715,14 +13955,14 @@
       </p:sp>
       <p:pic>
         <p:nvPicPr>
-          <p:cNvPr id="11" name="Image 1" descr="preencoded.png">    </p:cNvPr>
+          <p:cNvPr id="12" name="Image 2" descr="preencoded.png">    </p:cNvPr>
           <p:cNvPicPr>
             <a:picLocks noChangeAspect="1"/>
           </p:cNvPicPr>
           <p:nvPr/>
         </p:nvPicPr>
         <p:blipFill>
-          <a:blip r:embed="rId2"/>
+          <a:blip r:embed="rId3"/>
           <a:stretch>
             <a:fillRect/>
           </a:stretch>
@@ -13739,7 +13979,7 @@
       </p:pic>
       <p:sp>
         <p:nvSpPr>
-          <p:cNvPr id="12" name="Text 8"/>
+          <p:cNvPr id="13" name="Text 8"/>
           <p:cNvSpPr/>
           <p:nvPr/>
         </p:nvSpPr>
@@ -13778,7 +14018,7 @@
       </p:sp>
       <p:sp>
         <p:nvSpPr>
-          <p:cNvPr id="13" name="Text 9"/>
+          <p:cNvPr id="14" name="Text 9"/>
           <p:cNvSpPr/>
           <p:nvPr/>
         </p:nvSpPr>
@@ -13817,7 +14057,7 @@
       </p:sp>
       <p:sp>
         <p:nvSpPr>
-          <p:cNvPr id="14" name="Shape 10"/>
+          <p:cNvPr id="15" name="Shape 10"/>
           <p:cNvSpPr/>
           <p:nvPr/>
         </p:nvSpPr>
@@ -13849,14 +14089,14 @@
       </p:sp>
       <p:pic>
         <p:nvPicPr>
-          <p:cNvPr id="15" name="Image 2" descr="preencoded.png">    </p:cNvPr>
+          <p:cNvPr id="16" name="Image 3" descr="preencoded.png">    </p:cNvPr>
           <p:cNvPicPr>
             <a:picLocks noChangeAspect="1"/>
           </p:cNvPicPr>
           <p:nvPr/>
         </p:nvPicPr>
         <p:blipFill>
-          <a:blip r:embed="rId3"/>
+          <a:blip r:embed="rId4"/>
           <a:stretch>
             <a:fillRect/>
           </a:stretch>
@@ -13873,7 +14113,7 @@
       </p:pic>
       <p:sp>
         <p:nvSpPr>
-          <p:cNvPr id="16" name="Text 11"/>
+          <p:cNvPr id="17" name="Text 11"/>
           <p:cNvSpPr/>
           <p:nvPr/>
         </p:nvSpPr>
@@ -13912,7 +14152,7 @@
       </p:sp>
       <p:sp>
         <p:nvSpPr>
-          <p:cNvPr id="17" name="Text 12"/>
+          <p:cNvPr id="18" name="Text 12"/>
           <p:cNvSpPr/>
           <p:nvPr/>
         </p:nvSpPr>
@@ -13951,7 +14191,7 @@
       </p:sp>
       <p:sp>
         <p:nvSpPr>
-          <p:cNvPr id="18" name="Shape 13"/>
+          <p:cNvPr id="19" name="Shape 13"/>
           <p:cNvSpPr/>
           <p:nvPr/>
         </p:nvSpPr>
@@ -13983,14 +14223,14 @@
       </p:sp>
       <p:pic>
         <p:nvPicPr>
-          <p:cNvPr id="19" name="Image 3" descr="preencoded.png">    </p:cNvPr>
+          <p:cNvPr id="20" name="Image 4" descr="preencoded.png">    </p:cNvPr>
           <p:cNvPicPr>
             <a:picLocks noChangeAspect="1"/>
           </p:cNvPicPr>
           <p:nvPr/>
         </p:nvPicPr>
         <p:blipFill>
-          <a:blip r:embed="rId4"/>
+          <a:blip r:embed="rId5"/>
           <a:stretch>
             <a:fillRect/>
           </a:stretch>
@@ -14007,7 +14247,7 @@
       </p:pic>
       <p:sp>
         <p:nvSpPr>
-          <p:cNvPr id="20" name="Text 14"/>
+          <p:cNvPr id="21" name="Text 14"/>
           <p:cNvSpPr/>
           <p:nvPr/>
         </p:nvSpPr>
@@ -14046,7 +14286,7 @@
       </p:sp>
       <p:sp>
         <p:nvSpPr>
-          <p:cNvPr id="21" name="Text 15"/>
+          <p:cNvPr id="22" name="Text 15"/>
           <p:cNvSpPr/>
           <p:nvPr/>
         </p:nvSpPr>
@@ -14085,7 +14325,7 @@
       </p:sp>
       <p:sp>
         <p:nvSpPr>
-          <p:cNvPr id="22" name="Shape 16"/>
+          <p:cNvPr id="23" name="Shape 16"/>
           <p:cNvSpPr/>
           <p:nvPr/>
         </p:nvSpPr>
@@ -14110,7 +14350,7 @@
       </p:sp>
       <p:sp>
         <p:nvSpPr>
-          <p:cNvPr id="23" name="Text 17"/>
+          <p:cNvPr id="24" name="Text 17"/>
           <p:cNvSpPr/>
           <p:nvPr/>
         </p:nvSpPr>
@@ -14204,16 +14444,40 @@
           </a:ln>
         </p:spPr>
       </p:sp>
-      <p:sp>
-        <p:nvSpPr>
-          <p:cNvPr id="3" name="Text 1"/>
-          <p:cNvSpPr/>
-          <p:nvPr/>
-        </p:nvSpPr>
-        <p:spPr>
-          <a:xfrm>
-            <a:off x="365760" y="0"/>
-            <a:ext cx="8412480" cy="365760"/>
+      <p:pic>
+        <p:nvPicPr>
+          <p:cNvPr id="3" name="Image 0" descr="preencoded.png">    </p:cNvPr>
+          <p:cNvPicPr>
+            <a:picLocks noChangeAspect="1"/>
+          </p:cNvPicPr>
+          <p:nvPr/>
+        </p:nvPicPr>
+        <p:blipFill>
+          <a:blip r:embed="rId1"/>
+          <a:stretch>
+            <a:fillRect/>
+          </a:stretch>
+        </p:blipFill>
+        <p:spPr>
+          <a:xfrm>
+            <a:off x="91440" y="36576"/>
+            <a:ext cx="292608" cy="292608"/>
+          </a:xfrm>
+          <a:prstGeom prst="rect">
+            <a:avLst/>
+          </a:prstGeom>
+        </p:spPr>
+      </p:pic>
+      <p:sp>
+        <p:nvSpPr>
+          <p:cNvPr id="4" name="Text 1"/>
+          <p:cNvSpPr/>
+          <p:nvPr/>
+        </p:nvSpPr>
+        <p:spPr>
+          <a:xfrm>
+            <a:off x="457200" y="0"/>
+            <a:ext cx="8229600" cy="365760"/>
           </a:xfrm>
           <a:prstGeom prst="rect">
             <a:avLst/>
@@ -14237,7 +14501,7 @@
                 <a:ea typeface="Calibri" pitchFamily="34" charset="-122"/>
                 <a:cs typeface="Calibri" pitchFamily="34" charset="-120"/>
               </a:rPr>
-              <a:t>CSHSE · AI Import Wizard · User Guide</a:t>
+              <a:t>AI Import Wizard · User Guide</a:t>
             </a:r>
             <a:endParaRPr lang="en-US" sz="1000" dirty="0"/>
           </a:p>
@@ -14245,7 +14509,7 @@
       </p:sp>
       <p:sp>
         <p:nvSpPr>
-          <p:cNvPr id="4" name="Text 2"/>
+          <p:cNvPr id="5" name="Text 2"/>
           <p:cNvSpPr/>
           <p:nvPr/>
         </p:nvSpPr>
@@ -14284,7 +14548,7 @@
       </p:sp>
       <p:sp>
         <p:nvSpPr>
-          <p:cNvPr id="5" name="Text 3"/>
+          <p:cNvPr id="6" name="Text 3"/>
           <p:cNvSpPr/>
           <p:nvPr/>
         </p:nvSpPr>
@@ -14323,7 +14587,7 @@
       </p:sp>
       <p:sp>
         <p:nvSpPr>
-          <p:cNvPr id="6" name="Shape 4"/>
+          <p:cNvPr id="7" name="Shape 4"/>
           <p:cNvSpPr/>
           <p:nvPr/>
         </p:nvSpPr>
@@ -14355,7 +14619,7 @@
       </p:sp>
       <p:sp>
         <p:nvSpPr>
-          <p:cNvPr id="7" name="Text 5"/>
+          <p:cNvPr id="8" name="Text 5"/>
           <p:cNvSpPr/>
           <p:nvPr/>
         </p:nvSpPr>
@@ -14394,7 +14658,7 @@
       </p:sp>
       <p:sp>
         <p:nvSpPr>
-          <p:cNvPr id="8" name="Text 6"/>
+          <p:cNvPr id="9" name="Text 6"/>
           <p:cNvSpPr/>
           <p:nvPr/>
         </p:nvSpPr>
@@ -14548,7 +14812,7 @@
       </p:sp>
       <p:sp>
         <p:nvSpPr>
-          <p:cNvPr id="9" name="Shape 7"/>
+          <p:cNvPr id="10" name="Shape 7"/>
           <p:cNvSpPr/>
           <p:nvPr/>
         </p:nvSpPr>
@@ -14580,7 +14844,7 @@
       </p:sp>
       <p:sp>
         <p:nvSpPr>
-          <p:cNvPr id="10" name="Shape 8"/>
+          <p:cNvPr id="11" name="Shape 8"/>
           <p:cNvSpPr/>
           <p:nvPr/>
         </p:nvSpPr>
@@ -14605,7 +14869,7 @@
       </p:sp>
       <p:sp>
         <p:nvSpPr>
-          <p:cNvPr id="11" name="Text 9"/>
+          <p:cNvPr id="12" name="Text 9"/>
           <p:cNvSpPr/>
           <p:nvPr/>
         </p:nvSpPr>
@@ -14644,7 +14908,7 @@
       </p:sp>
       <p:sp>
         <p:nvSpPr>
-          <p:cNvPr id="12" name="Text 10"/>
+          <p:cNvPr id="13" name="Text 10"/>
           <p:cNvSpPr/>
           <p:nvPr/>
         </p:nvSpPr>
@@ -14771,7 +15035,7 @@
       </p:sp>
       <p:sp>
         <p:nvSpPr>
-          <p:cNvPr id="13" name="Shape 11"/>
+          <p:cNvPr id="14" name="Shape 11"/>
           <p:cNvSpPr/>
           <p:nvPr/>
         </p:nvSpPr>
@@ -14796,7 +15060,7 @@
       </p:sp>
       <p:sp>
         <p:nvSpPr>
-          <p:cNvPr id="14" name="Text 12"/>
+          <p:cNvPr id="15" name="Text 12"/>
           <p:cNvSpPr/>
           <p:nvPr/>
         </p:nvSpPr>
@@ -14890,16 +15154,40 @@
           </a:ln>
         </p:spPr>
       </p:sp>
-      <p:sp>
-        <p:nvSpPr>
-          <p:cNvPr id="3" name="Text 1"/>
-          <p:cNvSpPr/>
-          <p:nvPr/>
-        </p:nvSpPr>
-        <p:spPr>
-          <a:xfrm>
-            <a:off x="365760" y="0"/>
-            <a:ext cx="8412480" cy="365760"/>
+      <p:pic>
+        <p:nvPicPr>
+          <p:cNvPr id="3" name="Image 0" descr="preencoded.png">    </p:cNvPr>
+          <p:cNvPicPr>
+            <a:picLocks noChangeAspect="1"/>
+          </p:cNvPicPr>
+          <p:nvPr/>
+        </p:nvPicPr>
+        <p:blipFill>
+          <a:blip r:embed="rId1"/>
+          <a:stretch>
+            <a:fillRect/>
+          </a:stretch>
+        </p:blipFill>
+        <p:spPr>
+          <a:xfrm>
+            <a:off x="91440" y="36576"/>
+            <a:ext cx="292608" cy="292608"/>
+          </a:xfrm>
+          <a:prstGeom prst="rect">
+            <a:avLst/>
+          </a:prstGeom>
+        </p:spPr>
+      </p:pic>
+      <p:sp>
+        <p:nvSpPr>
+          <p:cNvPr id="4" name="Text 1"/>
+          <p:cNvSpPr/>
+          <p:nvPr/>
+        </p:nvSpPr>
+        <p:spPr>
+          <a:xfrm>
+            <a:off x="457200" y="0"/>
+            <a:ext cx="8229600" cy="365760"/>
           </a:xfrm>
           <a:prstGeom prst="rect">
             <a:avLst/>
@@ -14923,7 +15211,7 @@
                 <a:ea typeface="Calibri" pitchFamily="34" charset="-122"/>
                 <a:cs typeface="Calibri" pitchFamily="34" charset="-120"/>
               </a:rPr>
-              <a:t>CSHSE · AI Import Wizard · User Guide</a:t>
+              <a:t>AI Import Wizard · User Guide</a:t>
             </a:r>
             <a:endParaRPr lang="en-US" sz="1000" dirty="0"/>
           </a:p>
@@ -14931,7 +15219,7 @@
       </p:sp>
       <p:sp>
         <p:nvSpPr>
-          <p:cNvPr id="4" name="Text 2"/>
+          <p:cNvPr id="5" name="Text 2"/>
           <p:cNvSpPr/>
           <p:nvPr/>
         </p:nvSpPr>
@@ -14970,7 +15258,7 @@
       </p:sp>
       <p:sp>
         <p:nvSpPr>
-          <p:cNvPr id="5" name="Text 3"/>
+          <p:cNvPr id="6" name="Text 3"/>
           <p:cNvSpPr/>
           <p:nvPr/>
         </p:nvSpPr>
@@ -15009,7 +15297,7 @@
       </p:sp>
       <p:sp>
         <p:nvSpPr>
-          <p:cNvPr id="6" name="Shape 4"/>
+          <p:cNvPr id="7" name="Shape 4"/>
           <p:cNvSpPr/>
           <p:nvPr/>
         </p:nvSpPr>
@@ -15041,7 +15329,7 @@
       </p:sp>
       <p:sp>
         <p:nvSpPr>
-          <p:cNvPr id="7" name="Shape 5"/>
+          <p:cNvPr id="8" name="Shape 5"/>
           <p:cNvSpPr/>
           <p:nvPr/>
         </p:nvSpPr>
@@ -15066,7 +15354,7 @@
       </p:sp>
       <p:sp>
         <p:nvSpPr>
-          <p:cNvPr id="8" name="Text 6"/>
+          <p:cNvPr id="9" name="Text 6"/>
           <p:cNvSpPr/>
           <p:nvPr/>
         </p:nvSpPr>
@@ -15105,7 +15393,7 @@
       </p:sp>
       <p:sp>
         <p:nvSpPr>
-          <p:cNvPr id="9" name="Text 7"/>
+          <p:cNvPr id="10" name="Text 7"/>
           <p:cNvSpPr/>
           <p:nvPr/>
         </p:nvSpPr>
@@ -15144,7 +15432,7 @@
       </p:sp>
       <p:sp>
         <p:nvSpPr>
-          <p:cNvPr id="10" name="Shape 8"/>
+          <p:cNvPr id="11" name="Shape 8"/>
           <p:cNvSpPr/>
           <p:nvPr/>
         </p:nvSpPr>
@@ -15176,7 +15464,7 @@
       </p:sp>
       <p:sp>
         <p:nvSpPr>
-          <p:cNvPr id="11" name="Shape 9"/>
+          <p:cNvPr id="12" name="Shape 9"/>
           <p:cNvSpPr/>
           <p:nvPr/>
         </p:nvSpPr>
@@ -15201,7 +15489,7 @@
       </p:sp>
       <p:sp>
         <p:nvSpPr>
-          <p:cNvPr id="12" name="Text 10"/>
+          <p:cNvPr id="13" name="Text 10"/>
           <p:cNvSpPr/>
           <p:nvPr/>
         </p:nvSpPr>
@@ -15240,7 +15528,7 @@
       </p:sp>
       <p:sp>
         <p:nvSpPr>
-          <p:cNvPr id="13" name="Text 11"/>
+          <p:cNvPr id="14" name="Text 11"/>
           <p:cNvSpPr/>
           <p:nvPr/>
         </p:nvSpPr>
@@ -15279,7 +15567,7 @@
       </p:sp>
       <p:sp>
         <p:nvSpPr>
-          <p:cNvPr id="14" name="Shape 12"/>
+          <p:cNvPr id="15" name="Shape 12"/>
           <p:cNvSpPr/>
           <p:nvPr/>
         </p:nvSpPr>
@@ -15311,7 +15599,7 @@
       </p:sp>
       <p:sp>
         <p:nvSpPr>
-          <p:cNvPr id="15" name="Shape 13"/>
+          <p:cNvPr id="16" name="Shape 13"/>
           <p:cNvSpPr/>
           <p:nvPr/>
         </p:nvSpPr>
@@ -15336,7 +15624,7 @@
       </p:sp>
       <p:sp>
         <p:nvSpPr>
-          <p:cNvPr id="16" name="Text 14"/>
+          <p:cNvPr id="17" name="Text 14"/>
           <p:cNvSpPr/>
           <p:nvPr/>
         </p:nvSpPr>
@@ -15375,7 +15663,7 @@
       </p:sp>
       <p:sp>
         <p:nvSpPr>
-          <p:cNvPr id="17" name="Text 15"/>
+          <p:cNvPr id="18" name="Text 15"/>
           <p:cNvSpPr/>
           <p:nvPr/>
         </p:nvSpPr>
@@ -15414,7 +15702,7 @@
       </p:sp>
       <p:sp>
         <p:nvSpPr>
-          <p:cNvPr id="18" name="Shape 16"/>
+          <p:cNvPr id="19" name="Shape 16"/>
           <p:cNvSpPr/>
           <p:nvPr/>
         </p:nvSpPr>
@@ -15446,7 +15734,7 @@
       </p:sp>
       <p:sp>
         <p:nvSpPr>
-          <p:cNvPr id="19" name="Shape 17"/>
+          <p:cNvPr id="20" name="Shape 17"/>
           <p:cNvSpPr/>
           <p:nvPr/>
         </p:nvSpPr>
@@ -15471,7 +15759,7 @@
       </p:sp>
       <p:sp>
         <p:nvSpPr>
-          <p:cNvPr id="20" name="Text 18"/>
+          <p:cNvPr id="21" name="Text 18"/>
           <p:cNvSpPr/>
           <p:nvPr/>
         </p:nvSpPr>
@@ -15510,7 +15798,7 @@
       </p:sp>
       <p:sp>
         <p:nvSpPr>
-          <p:cNvPr id="21" name="Text 19"/>
+          <p:cNvPr id="22" name="Text 19"/>
           <p:cNvSpPr/>
           <p:nvPr/>
         </p:nvSpPr>
@@ -15549,7 +15837,7 @@
       </p:sp>
       <p:sp>
         <p:nvSpPr>
-          <p:cNvPr id="22" name="Shape 20"/>
+          <p:cNvPr id="23" name="Shape 20"/>
           <p:cNvSpPr/>
           <p:nvPr/>
         </p:nvSpPr>
@@ -15581,7 +15869,7 @@
       </p:sp>
       <p:sp>
         <p:nvSpPr>
-          <p:cNvPr id="23" name="Shape 21"/>
+          <p:cNvPr id="24" name="Shape 21"/>
           <p:cNvSpPr/>
           <p:nvPr/>
         </p:nvSpPr>
@@ -15606,7 +15894,7 @@
       </p:sp>
       <p:sp>
         <p:nvSpPr>
-          <p:cNvPr id="24" name="Text 22"/>
+          <p:cNvPr id="25" name="Text 22"/>
           <p:cNvSpPr/>
           <p:nvPr/>
         </p:nvSpPr>
@@ -15645,7 +15933,7 @@
       </p:sp>
       <p:sp>
         <p:nvSpPr>
-          <p:cNvPr id="25" name="Text 23"/>
+          <p:cNvPr id="26" name="Text 23"/>
           <p:cNvSpPr/>
           <p:nvPr/>
         </p:nvSpPr>
@@ -15684,7 +15972,7 @@
       </p:sp>
       <p:sp>
         <p:nvSpPr>
-          <p:cNvPr id="26" name="Shape 24"/>
+          <p:cNvPr id="27" name="Shape 24"/>
           <p:cNvSpPr/>
           <p:nvPr/>
         </p:nvSpPr>
@@ -15716,7 +16004,7 @@
       </p:sp>
       <p:sp>
         <p:nvSpPr>
-          <p:cNvPr id="27" name="Shape 25"/>
+          <p:cNvPr id="28" name="Shape 25"/>
           <p:cNvSpPr/>
           <p:nvPr/>
         </p:nvSpPr>
@@ -15741,7 +16029,7 @@
       </p:sp>
       <p:sp>
         <p:nvSpPr>
-          <p:cNvPr id="28" name="Text 26"/>
+          <p:cNvPr id="29" name="Text 26"/>
           <p:cNvSpPr/>
           <p:nvPr/>
         </p:nvSpPr>
@@ -15780,7 +16068,7 @@
       </p:sp>
       <p:sp>
         <p:nvSpPr>
-          <p:cNvPr id="29" name="Text 27"/>
+          <p:cNvPr id="30" name="Text 27"/>
           <p:cNvSpPr/>
           <p:nvPr/>
         </p:nvSpPr>
@@ -15819,7 +16107,7 @@
       </p:sp>
       <p:sp>
         <p:nvSpPr>
-          <p:cNvPr id="30" name="Shape 28"/>
+          <p:cNvPr id="31" name="Shape 28"/>
           <p:cNvSpPr/>
           <p:nvPr/>
         </p:nvSpPr>
@@ -15851,7 +16139,7 @@
       </p:sp>
       <p:sp>
         <p:nvSpPr>
-          <p:cNvPr id="31" name="Shape 29"/>
+          <p:cNvPr id="32" name="Shape 29"/>
           <p:cNvSpPr/>
           <p:nvPr/>
         </p:nvSpPr>
@@ -15876,7 +16164,7 @@
       </p:sp>
       <p:sp>
         <p:nvSpPr>
-          <p:cNvPr id="32" name="Text 30"/>
+          <p:cNvPr id="33" name="Text 30"/>
           <p:cNvSpPr/>
           <p:nvPr/>
         </p:nvSpPr>
@@ -15915,7 +16203,7 @@
       </p:sp>
       <p:sp>
         <p:nvSpPr>
-          <p:cNvPr id="33" name="Text 31"/>
+          <p:cNvPr id="34" name="Text 31"/>
           <p:cNvSpPr/>
           <p:nvPr/>
         </p:nvSpPr>
@@ -15954,7 +16242,7 @@
       </p:sp>
       <p:sp>
         <p:nvSpPr>
-          <p:cNvPr id="34" name="Shape 32"/>
+          <p:cNvPr id="35" name="Shape 32"/>
           <p:cNvSpPr/>
           <p:nvPr/>
         </p:nvSpPr>
@@ -15986,7 +16274,7 @@
       </p:sp>
       <p:sp>
         <p:nvSpPr>
-          <p:cNvPr id="35" name="Text 33"/>
+          <p:cNvPr id="36" name="Text 33"/>
           <p:cNvSpPr/>
           <p:nvPr/>
         </p:nvSpPr>
@@ -16025,7 +16313,7 @@
       </p:sp>
       <p:sp>
         <p:nvSpPr>
-          <p:cNvPr id="36" name="Text 34"/>
+          <p:cNvPr id="37" name="Text 34"/>
           <p:cNvSpPr/>
           <p:nvPr/>
         </p:nvSpPr>
@@ -16152,7 +16440,7 @@
       </p:sp>
       <p:sp>
         <p:nvSpPr>
-          <p:cNvPr id="37" name="Shape 35"/>
+          <p:cNvPr id="38" name="Shape 35"/>
           <p:cNvSpPr/>
           <p:nvPr/>
         </p:nvSpPr>
@@ -16184,7 +16472,7 @@
       </p:sp>
       <p:sp>
         <p:nvSpPr>
-          <p:cNvPr id="38" name="Shape 36"/>
+          <p:cNvPr id="39" name="Shape 36"/>
           <p:cNvSpPr/>
           <p:nvPr/>
         </p:nvSpPr>
@@ -16209,7 +16497,7 @@
       </p:sp>
       <p:sp>
         <p:nvSpPr>
-          <p:cNvPr id="39" name="Text 37"/>
+          <p:cNvPr id="40" name="Text 37"/>
           <p:cNvSpPr/>
           <p:nvPr/>
         </p:nvSpPr>
@@ -16248,7 +16536,7 @@
       </p:sp>
       <p:sp>
         <p:nvSpPr>
-          <p:cNvPr id="40" name="Text 38"/>
+          <p:cNvPr id="41" name="Text 38"/>
           <p:cNvSpPr/>
           <p:nvPr/>
         </p:nvSpPr>
@@ -16350,7 +16638,7 @@
       </p:sp>
       <p:sp>
         <p:nvSpPr>
-          <p:cNvPr id="41" name="Shape 39"/>
+          <p:cNvPr id="42" name="Shape 39"/>
           <p:cNvSpPr/>
           <p:nvPr/>
         </p:nvSpPr>
@@ -16375,7 +16663,7 @@
       </p:sp>
       <p:sp>
         <p:nvSpPr>
-          <p:cNvPr id="42" name="Text 40"/>
+          <p:cNvPr id="43" name="Text 40"/>
           <p:cNvSpPr/>
           <p:nvPr/>
         </p:nvSpPr>
@@ -16469,16 +16757,40 @@
           </a:ln>
         </p:spPr>
       </p:sp>
-      <p:sp>
-        <p:nvSpPr>
-          <p:cNvPr id="3" name="Text 1"/>
-          <p:cNvSpPr/>
-          <p:nvPr/>
-        </p:nvSpPr>
-        <p:spPr>
-          <a:xfrm>
-            <a:off x="365760" y="0"/>
-            <a:ext cx="8412480" cy="365760"/>
+      <p:pic>
+        <p:nvPicPr>
+          <p:cNvPr id="3" name="Image 0" descr="preencoded.png">    </p:cNvPr>
+          <p:cNvPicPr>
+            <a:picLocks noChangeAspect="1"/>
+          </p:cNvPicPr>
+          <p:nvPr/>
+        </p:nvPicPr>
+        <p:blipFill>
+          <a:blip r:embed="rId1"/>
+          <a:stretch>
+            <a:fillRect/>
+          </a:stretch>
+        </p:blipFill>
+        <p:spPr>
+          <a:xfrm>
+            <a:off x="91440" y="36576"/>
+            <a:ext cx="292608" cy="292608"/>
+          </a:xfrm>
+          <a:prstGeom prst="rect">
+            <a:avLst/>
+          </a:prstGeom>
+        </p:spPr>
+      </p:pic>
+      <p:sp>
+        <p:nvSpPr>
+          <p:cNvPr id="4" name="Text 1"/>
+          <p:cNvSpPr/>
+          <p:nvPr/>
+        </p:nvSpPr>
+        <p:spPr>
+          <a:xfrm>
+            <a:off x="457200" y="0"/>
+            <a:ext cx="8229600" cy="365760"/>
           </a:xfrm>
           <a:prstGeom prst="rect">
             <a:avLst/>
@@ -16502,7 +16814,7 @@
                 <a:ea typeface="Calibri" pitchFamily="34" charset="-122"/>
                 <a:cs typeface="Calibri" pitchFamily="34" charset="-120"/>
               </a:rPr>
-              <a:t>CSHSE · AI Import Wizard · User Guide</a:t>
+              <a:t>AI Import Wizard · User Guide</a:t>
             </a:r>
             <a:endParaRPr lang="en-US" sz="1000" dirty="0"/>
           </a:p>
@@ -16510,7 +16822,7 @@
       </p:sp>
       <p:sp>
         <p:nvSpPr>
-          <p:cNvPr id="4" name="Text 2"/>
+          <p:cNvPr id="5" name="Text 2"/>
           <p:cNvSpPr/>
           <p:nvPr/>
         </p:nvSpPr>
@@ -16549,7 +16861,7 @@
       </p:sp>
       <p:sp>
         <p:nvSpPr>
-          <p:cNvPr id="5" name="Text 3"/>
+          <p:cNvPr id="6" name="Text 3"/>
           <p:cNvSpPr/>
           <p:nvPr/>
         </p:nvSpPr>
@@ -16588,7 +16900,7 @@
       </p:sp>
       <p:sp>
         <p:nvSpPr>
-          <p:cNvPr id="6" name="Shape 4"/>
+          <p:cNvPr id="7" name="Shape 4"/>
           <p:cNvSpPr/>
           <p:nvPr/>
         </p:nvSpPr>
@@ -16620,7 +16932,7 @@
       </p:sp>
       <p:sp>
         <p:nvSpPr>
-          <p:cNvPr id="7" name="Shape 5"/>
+          <p:cNvPr id="8" name="Shape 5"/>
           <p:cNvSpPr/>
           <p:nvPr/>
         </p:nvSpPr>
@@ -16645,14 +16957,14 @@
       </p:sp>
       <p:pic>
         <p:nvPicPr>
-          <p:cNvPr id="8" name="Image 0" descr="preencoded.png">    </p:cNvPr>
+          <p:cNvPr id="9" name="Image 1" descr="preencoded.png">    </p:cNvPr>
           <p:cNvPicPr>
             <a:picLocks noChangeAspect="1"/>
           </p:cNvPicPr>
           <p:nvPr/>
         </p:nvPicPr>
         <p:blipFill>
-          <a:blip r:embed="rId1"/>
+          <a:blip r:embed="rId2"/>
           <a:stretch>
             <a:fillRect/>
           </a:stretch>
@@ -16669,7 +16981,7 @@
       </p:pic>
       <p:sp>
         <p:nvSpPr>
-          <p:cNvPr id="9" name="Text 6"/>
+          <p:cNvPr id="10" name="Text 6"/>
           <p:cNvSpPr/>
           <p:nvPr/>
         </p:nvSpPr>
@@ -16708,7 +17020,7 @@
       </p:sp>
       <p:sp>
         <p:nvSpPr>
-          <p:cNvPr id="10" name="Text 7"/>
+          <p:cNvPr id="11" name="Text 7"/>
           <p:cNvSpPr/>
           <p:nvPr/>
         </p:nvSpPr>
@@ -16835,7 +17147,7 @@
       </p:sp>
       <p:sp>
         <p:nvSpPr>
-          <p:cNvPr id="11" name="Shape 8"/>
+          <p:cNvPr id="12" name="Shape 8"/>
           <p:cNvSpPr/>
           <p:nvPr/>
         </p:nvSpPr>
@@ -16867,7 +17179,7 @@
       </p:sp>
       <p:sp>
         <p:nvSpPr>
-          <p:cNvPr id="12" name="Shape 9"/>
+          <p:cNvPr id="13" name="Shape 9"/>
           <p:cNvSpPr/>
           <p:nvPr/>
         </p:nvSpPr>
@@ -16892,14 +17204,14 @@
       </p:sp>
       <p:pic>
         <p:nvPicPr>
-          <p:cNvPr id="13" name="Image 1" descr="preencoded.png">    </p:cNvPr>
+          <p:cNvPr id="14" name="Image 2" descr="preencoded.png">    </p:cNvPr>
           <p:cNvPicPr>
             <a:picLocks noChangeAspect="1"/>
           </p:cNvPicPr>
           <p:nvPr/>
         </p:nvPicPr>
         <p:blipFill>
-          <a:blip r:embed="rId2"/>
+          <a:blip r:embed="rId3"/>
           <a:stretch>
             <a:fillRect/>
           </a:stretch>
@@ -16916,7 +17228,7 @@
       </p:pic>
       <p:sp>
         <p:nvSpPr>
-          <p:cNvPr id="14" name="Text 10"/>
+          <p:cNvPr id="15" name="Text 10"/>
           <p:cNvSpPr/>
           <p:nvPr/>
         </p:nvSpPr>
@@ -16955,7 +17267,7 @@
       </p:sp>
       <p:sp>
         <p:nvSpPr>
-          <p:cNvPr id="15" name="Text 11"/>
+          <p:cNvPr id="16" name="Text 11"/>
           <p:cNvSpPr/>
           <p:nvPr/>
         </p:nvSpPr>
@@ -17082,7 +17394,7 @@
       </p:sp>
       <p:sp>
         <p:nvSpPr>
-          <p:cNvPr id="16" name="Shape 12"/>
+          <p:cNvPr id="17" name="Shape 12"/>
           <p:cNvSpPr/>
           <p:nvPr/>
         </p:nvSpPr>
@@ -17114,7 +17426,7 @@
       </p:sp>
       <p:sp>
         <p:nvSpPr>
-          <p:cNvPr id="17" name="Shape 13"/>
+          <p:cNvPr id="18" name="Shape 13"/>
           <p:cNvSpPr/>
           <p:nvPr/>
         </p:nvSpPr>
@@ -17139,14 +17451,14 @@
       </p:sp>
       <p:pic>
         <p:nvPicPr>
-          <p:cNvPr id="18" name="Image 2" descr="preencoded.png">    </p:cNvPr>
+          <p:cNvPr id="19" name="Image 3" descr="preencoded.png">    </p:cNvPr>
           <p:cNvPicPr>
             <a:picLocks noChangeAspect="1"/>
           </p:cNvPicPr>
           <p:nvPr/>
         </p:nvPicPr>
         <p:blipFill>
-          <a:blip r:embed="rId3"/>
+          <a:blip r:embed="rId4"/>
           <a:stretch>
             <a:fillRect/>
           </a:stretch>
@@ -17163,7 +17475,7 @@
       </p:pic>
       <p:sp>
         <p:nvSpPr>
-          <p:cNvPr id="19" name="Text 14"/>
+          <p:cNvPr id="20" name="Text 14"/>
           <p:cNvSpPr/>
           <p:nvPr/>
         </p:nvSpPr>
@@ -17202,7 +17514,7 @@
       </p:sp>
       <p:sp>
         <p:nvSpPr>
-          <p:cNvPr id="20" name="Text 15"/>
+          <p:cNvPr id="21" name="Text 15"/>
           <p:cNvSpPr/>
           <p:nvPr/>
         </p:nvSpPr>
@@ -17308,7 +17620,7 @@
       </p:sp>
       <p:sp>
         <p:nvSpPr>
-          <p:cNvPr id="21" name="Shape 16"/>
+          <p:cNvPr id="22" name="Shape 16"/>
           <p:cNvSpPr/>
           <p:nvPr/>
         </p:nvSpPr>
@@ -17333,7 +17645,7 @@
       </p:sp>
       <p:sp>
         <p:nvSpPr>
-          <p:cNvPr id="22" name="Text 17"/>
+          <p:cNvPr id="23" name="Text 17"/>
           <p:cNvSpPr/>
           <p:nvPr/>
         </p:nvSpPr>
@@ -17427,16 +17739,40 @@
           </a:ln>
         </p:spPr>
       </p:sp>
-      <p:sp>
-        <p:nvSpPr>
-          <p:cNvPr id="3" name="Text 1"/>
-          <p:cNvSpPr/>
-          <p:nvPr/>
-        </p:nvSpPr>
-        <p:spPr>
-          <a:xfrm>
-            <a:off x="365760" y="0"/>
-            <a:ext cx="8412480" cy="365760"/>
+      <p:pic>
+        <p:nvPicPr>
+          <p:cNvPr id="3" name="Image 0" descr="preencoded.png">    </p:cNvPr>
+          <p:cNvPicPr>
+            <a:picLocks noChangeAspect="1"/>
+          </p:cNvPicPr>
+          <p:nvPr/>
+        </p:nvPicPr>
+        <p:blipFill>
+          <a:blip r:embed="rId1"/>
+          <a:stretch>
+            <a:fillRect/>
+          </a:stretch>
+        </p:blipFill>
+        <p:spPr>
+          <a:xfrm>
+            <a:off x="91440" y="36576"/>
+            <a:ext cx="292608" cy="292608"/>
+          </a:xfrm>
+          <a:prstGeom prst="rect">
+            <a:avLst/>
+          </a:prstGeom>
+        </p:spPr>
+      </p:pic>
+      <p:sp>
+        <p:nvSpPr>
+          <p:cNvPr id="4" name="Text 1"/>
+          <p:cNvSpPr/>
+          <p:nvPr/>
+        </p:nvSpPr>
+        <p:spPr>
+          <a:xfrm>
+            <a:off x="457200" y="0"/>
+            <a:ext cx="8229600" cy="365760"/>
           </a:xfrm>
           <a:prstGeom prst="rect">
             <a:avLst/>
@@ -17460,7 +17796,7 @@
                 <a:ea typeface="Calibri" pitchFamily="34" charset="-122"/>
                 <a:cs typeface="Calibri" pitchFamily="34" charset="-120"/>
               </a:rPr>
-              <a:t>CSHSE · AI Import Wizard · User Guide</a:t>
+              <a:t>AI Import Wizard · User Guide</a:t>
             </a:r>
             <a:endParaRPr lang="en-US" sz="1000" dirty="0"/>
           </a:p>
@@ -17468,7 +17804,7 @@
       </p:sp>
       <p:sp>
         <p:nvSpPr>
-          <p:cNvPr id="4" name="Text 2"/>
+          <p:cNvPr id="5" name="Text 2"/>
           <p:cNvSpPr/>
           <p:nvPr/>
         </p:nvSpPr>
@@ -17507,7 +17843,7 @@
       </p:sp>
       <p:sp>
         <p:nvSpPr>
-          <p:cNvPr id="5" name="Text 3"/>
+          <p:cNvPr id="6" name="Text 3"/>
           <p:cNvSpPr/>
           <p:nvPr/>
         </p:nvSpPr>
@@ -17546,7 +17882,7 @@
       </p:sp>
       <p:sp>
         <p:nvSpPr>
-          <p:cNvPr id="6" name="Shape 4"/>
+          <p:cNvPr id="7" name="Shape 4"/>
           <p:cNvSpPr/>
           <p:nvPr/>
         </p:nvSpPr>
@@ -17578,7 +17914,7 @@
       </p:sp>
       <p:sp>
         <p:nvSpPr>
-          <p:cNvPr id="7" name="Shape 5"/>
+          <p:cNvPr id="8" name="Shape 5"/>
           <p:cNvSpPr/>
           <p:nvPr/>
         </p:nvSpPr>
@@ -17603,7 +17939,7 @@
       </p:sp>
       <p:sp>
         <p:nvSpPr>
-          <p:cNvPr id="8" name="Text 6"/>
+          <p:cNvPr id="9" name="Text 6"/>
           <p:cNvSpPr/>
           <p:nvPr/>
         </p:nvSpPr>
@@ -17642,7 +17978,7 @@
       </p:sp>
       <p:sp>
         <p:nvSpPr>
-          <p:cNvPr id="9" name="Text 7"/>
+          <p:cNvPr id="10" name="Text 7"/>
           <p:cNvSpPr/>
           <p:nvPr/>
         </p:nvSpPr>
@@ -17681,7 +18017,7 @@
       </p:sp>
       <p:sp>
         <p:nvSpPr>
-          <p:cNvPr id="10" name="Text 8"/>
+          <p:cNvPr id="11" name="Text 8"/>
           <p:cNvSpPr/>
           <p:nvPr/>
         </p:nvSpPr>
@@ -17720,7 +18056,7 @@
       </p:sp>
       <p:sp>
         <p:nvSpPr>
-          <p:cNvPr id="11" name="Text 9"/>
+          <p:cNvPr id="12" name="Text 9"/>
           <p:cNvSpPr/>
           <p:nvPr/>
         </p:nvSpPr>
@@ -17759,7 +18095,7 @@
       </p:sp>
       <p:sp>
         <p:nvSpPr>
-          <p:cNvPr id="12" name="Text 10"/>
+          <p:cNvPr id="13" name="Text 10"/>
           <p:cNvSpPr/>
           <p:nvPr/>
         </p:nvSpPr>
@@ -17798,7 +18134,7 @@
       </p:sp>
       <p:sp>
         <p:nvSpPr>
-          <p:cNvPr id="13" name="Text 11"/>
+          <p:cNvPr id="14" name="Text 11"/>
           <p:cNvSpPr/>
           <p:nvPr/>
         </p:nvSpPr>
@@ -17834,7 +18170,7 @@
       </p:sp>
       <p:sp>
         <p:nvSpPr>
-          <p:cNvPr id="14" name="Text 12"/>
+          <p:cNvPr id="15" name="Text 12"/>
           <p:cNvSpPr/>
           <p:nvPr/>
         </p:nvSpPr>
@@ -17873,7 +18209,7 @@
       </p:sp>
       <p:sp>
         <p:nvSpPr>
-          <p:cNvPr id="15" name="Text 13"/>
+          <p:cNvPr id="16" name="Text 13"/>
           <p:cNvSpPr/>
           <p:nvPr/>
         </p:nvSpPr>
@@ -17912,7 +18248,7 @@
       </p:sp>
       <p:sp>
         <p:nvSpPr>
-          <p:cNvPr id="16" name="Text 14"/>
+          <p:cNvPr id="17" name="Text 14"/>
           <p:cNvSpPr/>
           <p:nvPr/>
         </p:nvSpPr>
@@ -17948,7 +18284,7 @@
       </p:sp>
       <p:sp>
         <p:nvSpPr>
-          <p:cNvPr id="17" name="Text 15"/>
+          <p:cNvPr id="18" name="Text 15"/>
           <p:cNvSpPr/>
           <p:nvPr/>
         </p:nvSpPr>
@@ -17987,7 +18323,7 @@
       </p:sp>
       <p:sp>
         <p:nvSpPr>
-          <p:cNvPr id="18" name="Text 16"/>
+          <p:cNvPr id="19" name="Text 16"/>
           <p:cNvSpPr/>
           <p:nvPr/>
         </p:nvSpPr>
@@ -18026,7 +18362,7 @@
       </p:sp>
       <p:sp>
         <p:nvSpPr>
-          <p:cNvPr id="19" name="Text 17"/>
+          <p:cNvPr id="20" name="Text 17"/>
           <p:cNvSpPr/>
           <p:nvPr/>
         </p:nvSpPr>
@@ -18062,7 +18398,7 @@
       </p:sp>
       <p:sp>
         <p:nvSpPr>
-          <p:cNvPr id="20" name="Text 18"/>
+          <p:cNvPr id="21" name="Text 18"/>
           <p:cNvSpPr/>
           <p:nvPr/>
         </p:nvSpPr>
@@ -18101,7 +18437,7 @@
       </p:sp>
       <p:sp>
         <p:nvSpPr>
-          <p:cNvPr id="21" name="Text 19"/>
+          <p:cNvPr id="22" name="Text 19"/>
           <p:cNvSpPr/>
           <p:nvPr/>
         </p:nvSpPr>
@@ -18140,7 +18476,7 @@
       </p:sp>
       <p:sp>
         <p:nvSpPr>
-          <p:cNvPr id="22" name="Text 20"/>
+          <p:cNvPr id="23" name="Text 20"/>
           <p:cNvSpPr/>
           <p:nvPr/>
         </p:nvSpPr>
@@ -18176,7 +18512,7 @@
       </p:sp>
       <p:sp>
         <p:nvSpPr>
-          <p:cNvPr id="23" name="Text 21"/>
+          <p:cNvPr id="24" name="Text 21"/>
           <p:cNvSpPr/>
           <p:nvPr/>
         </p:nvSpPr>
@@ -18215,7 +18551,7 @@
       </p:sp>
       <p:sp>
         <p:nvSpPr>
-          <p:cNvPr id="24" name="Text 22"/>
+          <p:cNvPr id="25" name="Text 22"/>
           <p:cNvSpPr/>
           <p:nvPr/>
         </p:nvSpPr>
@@ -18254,7 +18590,7 @@
       </p:sp>
       <p:sp>
         <p:nvSpPr>
-          <p:cNvPr id="25" name="Text 23"/>
+          <p:cNvPr id="26" name="Text 23"/>
           <p:cNvSpPr/>
           <p:nvPr/>
         </p:nvSpPr>
@@ -18290,7 +18626,7 @@
       </p:sp>
       <p:sp>
         <p:nvSpPr>
-          <p:cNvPr id="26" name="Text 24"/>
+          <p:cNvPr id="27" name="Text 24"/>
           <p:cNvSpPr/>
           <p:nvPr/>
         </p:nvSpPr>
@@ -18329,7 +18665,7 @@
       </p:sp>
       <p:sp>
         <p:nvSpPr>
-          <p:cNvPr id="27" name="Text 25"/>
+          <p:cNvPr id="28" name="Text 25"/>
           <p:cNvSpPr/>
           <p:nvPr/>
         </p:nvSpPr>
@@ -18368,7 +18704,7 @@
       </p:sp>
       <p:sp>
         <p:nvSpPr>
-          <p:cNvPr id="28" name="Text 26"/>
+          <p:cNvPr id="29" name="Text 26"/>
           <p:cNvSpPr/>
           <p:nvPr/>
         </p:nvSpPr>
@@ -18404,7 +18740,7 @@
       </p:sp>
       <p:sp>
         <p:nvSpPr>
-          <p:cNvPr id="29" name="Shape 27"/>
+          <p:cNvPr id="30" name="Shape 27"/>
           <p:cNvSpPr/>
           <p:nvPr/>
         </p:nvSpPr>
@@ -18436,7 +18772,7 @@
       </p:sp>
       <p:sp>
         <p:nvSpPr>
-          <p:cNvPr id="30" name="Text 28"/>
+          <p:cNvPr id="31" name="Text 28"/>
           <p:cNvSpPr/>
           <p:nvPr/>
         </p:nvSpPr>
@@ -18475,7 +18811,7 @@
       </p:sp>
       <p:sp>
         <p:nvSpPr>
-          <p:cNvPr id="31" name="Text 29"/>
+          <p:cNvPr id="32" name="Text 29"/>
           <p:cNvSpPr/>
           <p:nvPr/>
         </p:nvSpPr>
@@ -18718,7 +19054,7 @@
       </p:sp>
       <p:sp>
         <p:nvSpPr>
-          <p:cNvPr id="32" name="Shape 30"/>
+          <p:cNvPr id="33" name="Shape 30"/>
           <p:cNvSpPr/>
           <p:nvPr/>
         </p:nvSpPr>
@@ -18743,7 +19079,7 @@
       </p:sp>
       <p:sp>
         <p:nvSpPr>
-          <p:cNvPr id="33" name="Text 31"/>
+          <p:cNvPr id="34" name="Text 31"/>
           <p:cNvSpPr/>
           <p:nvPr/>
         </p:nvSpPr>
@@ -18837,16 +19173,40 @@
           </a:ln>
         </p:spPr>
       </p:sp>
-      <p:sp>
-        <p:nvSpPr>
-          <p:cNvPr id="3" name="Text 1"/>
-          <p:cNvSpPr/>
-          <p:nvPr/>
-        </p:nvSpPr>
-        <p:spPr>
-          <a:xfrm>
-            <a:off x="365760" y="0"/>
-            <a:ext cx="8412480" cy="365760"/>
+      <p:pic>
+        <p:nvPicPr>
+          <p:cNvPr id="3" name="Image 0" descr="preencoded.png">    </p:cNvPr>
+          <p:cNvPicPr>
+            <a:picLocks noChangeAspect="1"/>
+          </p:cNvPicPr>
+          <p:nvPr/>
+        </p:nvPicPr>
+        <p:blipFill>
+          <a:blip r:embed="rId1"/>
+          <a:stretch>
+            <a:fillRect/>
+          </a:stretch>
+        </p:blipFill>
+        <p:spPr>
+          <a:xfrm>
+            <a:off x="91440" y="36576"/>
+            <a:ext cx="292608" cy="292608"/>
+          </a:xfrm>
+          <a:prstGeom prst="rect">
+            <a:avLst/>
+          </a:prstGeom>
+        </p:spPr>
+      </p:pic>
+      <p:sp>
+        <p:nvSpPr>
+          <p:cNvPr id="4" name="Text 1"/>
+          <p:cNvSpPr/>
+          <p:nvPr/>
+        </p:nvSpPr>
+        <p:spPr>
+          <a:xfrm>
+            <a:off x="457200" y="0"/>
+            <a:ext cx="8229600" cy="365760"/>
           </a:xfrm>
           <a:prstGeom prst="rect">
             <a:avLst/>
@@ -18870,7 +19230,7 @@
                 <a:ea typeface="Calibri" pitchFamily="34" charset="-122"/>
                 <a:cs typeface="Calibri" pitchFamily="34" charset="-120"/>
               </a:rPr>
-              <a:t>CSHSE · AI Import Wizard · User Guide</a:t>
+              <a:t>AI Import Wizard · User Guide</a:t>
             </a:r>
             <a:endParaRPr lang="en-US" sz="1000" dirty="0"/>
           </a:p>
@@ -18878,7 +19238,7 @@
       </p:sp>
       <p:sp>
         <p:nvSpPr>
-          <p:cNvPr id="4" name="Text 2"/>
+          <p:cNvPr id="5" name="Text 2"/>
           <p:cNvSpPr/>
           <p:nvPr/>
         </p:nvSpPr>
@@ -18917,7 +19277,7 @@
       </p:sp>
       <p:sp>
         <p:nvSpPr>
-          <p:cNvPr id="5" name="Text 3"/>
+          <p:cNvPr id="6" name="Text 3"/>
           <p:cNvSpPr/>
           <p:nvPr/>
         </p:nvSpPr>
@@ -18956,7 +19316,7 @@
       </p:sp>
       <p:sp>
         <p:nvSpPr>
-          <p:cNvPr id="6" name="Shape 4"/>
+          <p:cNvPr id="7" name="Shape 4"/>
           <p:cNvSpPr/>
           <p:nvPr/>
         </p:nvSpPr>
@@ -18988,7 +19348,7 @@
       </p:sp>
       <p:sp>
         <p:nvSpPr>
-          <p:cNvPr id="7" name="Text 5"/>
+          <p:cNvPr id="8" name="Text 5"/>
           <p:cNvSpPr/>
           <p:nvPr/>
         </p:nvSpPr>
@@ -19027,7 +19387,7 @@
       </p:sp>
       <p:sp>
         <p:nvSpPr>
-          <p:cNvPr id="8" name="Shape 6"/>
+          <p:cNvPr id="9" name="Shape 6"/>
           <p:cNvSpPr/>
           <p:nvPr/>
         </p:nvSpPr>
@@ -19052,7 +19412,7 @@
       </p:sp>
       <p:sp>
         <p:nvSpPr>
-          <p:cNvPr id="9" name="Text 7"/>
+          <p:cNvPr id="10" name="Text 7"/>
           <p:cNvSpPr/>
           <p:nvPr/>
         </p:nvSpPr>
@@ -19091,7 +19451,7 @@
       </p:sp>
       <p:sp>
         <p:nvSpPr>
-          <p:cNvPr id="10" name="Shape 8"/>
+          <p:cNvPr id="11" name="Shape 8"/>
           <p:cNvSpPr/>
           <p:nvPr/>
         </p:nvSpPr>
@@ -19116,7 +19476,7 @@
       </p:sp>
       <p:sp>
         <p:nvSpPr>
-          <p:cNvPr id="11" name="Text 9"/>
+          <p:cNvPr id="12" name="Text 9"/>
           <p:cNvSpPr/>
           <p:nvPr/>
         </p:nvSpPr>
@@ -19155,7 +19515,7 @@
       </p:sp>
       <p:sp>
         <p:nvSpPr>
-          <p:cNvPr id="12" name="Shape 10"/>
+          <p:cNvPr id="13" name="Shape 10"/>
           <p:cNvSpPr/>
           <p:nvPr/>
         </p:nvSpPr>
@@ -19180,7 +19540,7 @@
       </p:sp>
       <p:sp>
         <p:nvSpPr>
-          <p:cNvPr id="13" name="Text 11"/>
+          <p:cNvPr id="14" name="Text 11"/>
           <p:cNvSpPr/>
           <p:nvPr/>
         </p:nvSpPr>
@@ -19219,7 +19579,7 @@
       </p:sp>
       <p:sp>
         <p:nvSpPr>
-          <p:cNvPr id="14" name="Shape 12"/>
+          <p:cNvPr id="15" name="Shape 12"/>
           <p:cNvSpPr/>
           <p:nvPr/>
         </p:nvSpPr>
@@ -19244,7 +19604,7 @@
       </p:sp>
       <p:sp>
         <p:nvSpPr>
-          <p:cNvPr id="15" name="Text 13"/>
+          <p:cNvPr id="16" name="Text 13"/>
           <p:cNvSpPr/>
           <p:nvPr/>
         </p:nvSpPr>
@@ -19283,7 +19643,7 @@
       </p:sp>
       <p:sp>
         <p:nvSpPr>
-          <p:cNvPr id="16" name="Shape 14"/>
+          <p:cNvPr id="17" name="Shape 14"/>
           <p:cNvSpPr/>
           <p:nvPr/>
         </p:nvSpPr>
@@ -19308,7 +19668,7 @@
       </p:sp>
       <p:sp>
         <p:nvSpPr>
-          <p:cNvPr id="17" name="Text 15"/>
+          <p:cNvPr id="18" name="Text 15"/>
           <p:cNvSpPr/>
           <p:nvPr/>
         </p:nvSpPr>
@@ -19347,7 +19707,7 @@
       </p:sp>
       <p:sp>
         <p:nvSpPr>
-          <p:cNvPr id="18" name="Text 16"/>
+          <p:cNvPr id="19" name="Text 16"/>
           <p:cNvSpPr/>
           <p:nvPr/>
         </p:nvSpPr>
@@ -19386,7 +19746,7 @@
       </p:sp>
       <p:sp>
         <p:nvSpPr>
-          <p:cNvPr id="19" name="Text 17"/>
+          <p:cNvPr id="20" name="Text 17"/>
           <p:cNvSpPr/>
           <p:nvPr/>
         </p:nvSpPr>
@@ -19425,7 +19785,7 @@
       </p:sp>
       <p:sp>
         <p:nvSpPr>
-          <p:cNvPr id="20" name="Shape 18"/>
+          <p:cNvPr id="21" name="Shape 18"/>
           <p:cNvSpPr/>
           <p:nvPr/>
         </p:nvSpPr>
@@ -19450,7 +19810,7 @@
       </p:sp>
       <p:sp>
         <p:nvSpPr>
-          <p:cNvPr id="21" name="Text 19"/>
+          <p:cNvPr id="22" name="Text 19"/>
           <p:cNvSpPr/>
           <p:nvPr/>
         </p:nvSpPr>
@@ -19489,7 +19849,7 @@
       </p:sp>
       <p:sp>
         <p:nvSpPr>
-          <p:cNvPr id="22" name="Shape 20"/>
+          <p:cNvPr id="23" name="Shape 20"/>
           <p:cNvSpPr/>
           <p:nvPr/>
         </p:nvSpPr>
@@ -19521,7 +19881,7 @@
       </p:sp>
       <p:sp>
         <p:nvSpPr>
-          <p:cNvPr id="23" name="Shape 21"/>
+          <p:cNvPr id="24" name="Shape 21"/>
           <p:cNvSpPr/>
           <p:nvPr/>
         </p:nvSpPr>
@@ -19546,7 +19906,7 @@
       </p:sp>
       <p:sp>
         <p:nvSpPr>
-          <p:cNvPr id="24" name="Text 22"/>
+          <p:cNvPr id="25" name="Text 22"/>
           <p:cNvSpPr/>
           <p:nvPr/>
         </p:nvSpPr>
@@ -19585,7 +19945,7 @@
       </p:sp>
       <p:sp>
         <p:nvSpPr>
-          <p:cNvPr id="25" name="Text 23"/>
+          <p:cNvPr id="26" name="Text 23"/>
           <p:cNvSpPr/>
           <p:nvPr/>
         </p:nvSpPr>
@@ -19791,7 +20151,7 @@
       </p:sp>
       <p:sp>
         <p:nvSpPr>
-          <p:cNvPr id="26" name="Shape 24"/>
+          <p:cNvPr id="27" name="Shape 24"/>
           <p:cNvSpPr/>
           <p:nvPr/>
         </p:nvSpPr>
@@ -19816,7 +20176,7 @@
       </p:sp>
       <p:sp>
         <p:nvSpPr>
-          <p:cNvPr id="27" name="Text 25"/>
+          <p:cNvPr id="28" name="Text 25"/>
           <p:cNvSpPr/>
           <p:nvPr/>
         </p:nvSpPr>

</xml_diff>